<commit_message>
Reenfocar el plan de Hosty56 en la gestión digital (Meta Ads)
Ajusta el alcance de ambos entregables: la gestión cubre únicamente
generar, calificar y filtrar interesados vía Meta Ads y entregarlos a
los propietarios. Se agrega una diapositiva/sección explícita de
"alcance" y "fuera de mi alcance" (NDA, llamadas, visitas, negociación,
legal y cierre quedan en manos de los propietarios). Se retiran el
guion de llamada telefónica y el protocolo de visita, reemplazados por
un protocolo de entrega de leads calificados. El honorario fijo cubre
la gestión digital; la comisión de éxito (3%) solo aplica si el
comprador final es entregado directamente por esta gestión.

Co-Authored-By: Claude Sonnet 5 <noreply@anthropic.com>
Claude-Session: https://claude.ai/code/session_01SmkHKcxHsRiRKSPUZSC2qb
</commit_message>
<xml_diff>
--- a/Hosty56 - Plan de Venta (Edificio Airbnb Bogota)/Hosty56_Plan_de_Venta.pptx
+++ b/Hosty56 - Plan de Venta (Edificio Airbnb Bogota)/Hosty56_Plan_de_Venta.pptx
@@ -517,7 +517,7 @@
             <a:r>
               <a:rPr lang="en-US" dirty="0"/>
               <a:t>OBJETIVO: Presentar el marco general antes de entrar al plan.
-MENSAJE PRINCIPAL: Este es un plan de venta discreto de un activo único, no una campaña de anuncios masiva.
+MENSAJE PRINCIPAL: Este es el plan de mi gestión digital — generar y filtrar interesados calificados vía Meta Ads. No cubre el proceso de negociación, visitas o cierre, que gestionan directamente los propietarios.
 QUÉ EXPLICAR: Portada de apertura.</a:t>
             </a:r>
             <a:endParaRPr lang="en-US" dirty="0"/>
@@ -607,8 +607,8 @@
             <a:r>
               <a:rPr lang="en-US" dirty="0"/>
               <a:t>OBJETIVO: Mostrar que la audiencia objetivo es amplia en tipo, pero estrecha en capacidad.
-MENSAJE PRINCIPAL: No se descarta ningún perfil; se descarta a quien no tenga capacidad de compra total.
-QUÉ EXPLICAR: La segmentación de Meta Ads debe cubrir estos cinco perfiles simultáneamente.</a:t>
+MENSAJE PRINCIPAL: No se descarta ningún perfil; el formulario de calificación descarta a quien no tenga capacidad de compra total.
+QUÉ EXPLICAR: La segmentación de Meta Ads debe cubrir estos cinco perfiles simultáneamente en la difusión discreta.</a:t>
             </a:r>
             <a:endParaRPr lang="en-US" dirty="0"/>
           </a:p>
@@ -696,9 +696,9 @@
           <a:p>
             <a:r>
               <a:rPr lang="en-US" dirty="0"/>
-              <a:t>OBJETIVO: Presentar con transparencia los dos frentes legales que pueden afectar el cierre.
-MENSAJE PRINCIPAL: Ni la hipoteca ni la sucesión son motivo para detener la campaña, pero deben resolverse o clarificarse en paralelo para no comprometer el plazo de 3 meses.
-QUÉ EXPLICAR: Recomendar a los propietarios confirmar con su abogado un cronograma estimado del proceso de sucesión; si no hay fecha clara, ajustar expectativas de cierre con el comprador antes de firmar cualquier compromiso.</a:t>
+              <a:t>OBJETIVO: Dejar explícito qué NO hago yo, para evitar expectativas fuera de lo acordado.
+MENSAJE PRINCIPAL: Mi gestión termina en la entrega de interesados calificados; todo lo demás (NDA, llamadas, visitas, negociación, legal, cierre) lo manejan directamente los propietarios.
+QUÉ EXPLICAR: Mencionar la hipoteca y la sucesión con transparencia, mostrando que es un tema conocido, pero aclarando que su resolución no depende de la campaña digital ni de mi gestión.</a:t>
             </a:r>
             <a:endParaRPr lang="en-US" dirty="0"/>
           </a:p>
@@ -786,9 +786,9 @@
           <a:p>
             <a:r>
               <a:rPr lang="en-US" dirty="0"/>
-              <a:t>OBJETIVO: Mostrar un plan de trabajo concreto para los primeros 3 meses.
-MENSAJE PRINCIPAL: El proceso avanza progresivamente: primero difusión, luego calificación y visitas, y finalmente negociación de cierre.
-QUÉ EXPLICAR: Si al final del mes 3 no hay cierre, el plan continúa (el cliente está abierto a extender el plazo), enfocándose en los interesados más avanzados.</a:t>
+              <a:t>OBJETIVO: Mostrar un plan de campaña concreto para los primeros 3 meses.
+MENSAJE PRINCIPAL: El proceso avanza progresivamente: lanzamiento, optimización, y escalamiento del volumen de interesados calificados entregados.
+QUÉ EXPLICAR: Si al final del mes 3 no hay un comprador cerrado, mi gestión digital puede continuar (el cliente está abierto a extender el plazo), mientras los propietarios avanzan en paralelo con los interesados ya entregados.</a:t>
             </a:r>
             <a:endParaRPr lang="en-US" dirty="0"/>
           </a:p>
@@ -876,9 +876,9 @@
           <a:p>
             <a:r>
               <a:rPr lang="en-US" dirty="0"/>
-              <a:t>OBJETIVO: Dar seguridad mostrando un cronograma detallado.
-MENSAJE PRINCIPAL: Cada quincena tiene un entregable concreto.
-QUÉ EXPLICAR: Las dos primeras semanas son de preparación técnica y legal, no de campaña activa todavía.</a:t>
+              <a:t>OBJETIVO: Dar seguridad mostrando un cronograma detallado de la gestión digital.
+MENSAJE PRINCIPAL: Cada quincena tiene un entregable concreto, siempre dentro del alcance de Meta Ads.
+QUÉ EXPLICAR: Las dos primeras semanas son de preparación de materiales digitales, no de campaña activa todavía.</a:t>
             </a:r>
             <a:endParaRPr lang="en-US" dirty="0"/>
           </a:p>
@@ -967,7 +967,7 @@
             <a:r>
               <a:rPr lang="en-US" dirty="0"/>
               <a:t>OBJETIVO: Presentar con claridad los dos componentes de honorarios y su condición de pago.
-MENSAJE PRINCIPAL: El fijo se paga siempre por la gestión; la comisión de éxito (3%, $120.000.000) solo aplica si el comprador final llega directamente por esta gestión.
+MENSAJE PRINCIPAL: El fijo se paga siempre por la gestión digital; la comisión de éxito (3%, $120.000.000) solo aplica si el comprador final llega directamente por esta gestión de Meta Ads.
 QUÉ EXPLICAR: Si el cierre ocurre por un contacto ajeno a esta campaña, solo se cobra el honorario fijo mensual.</a:t>
             </a:r>
             <a:endParaRPr lang="en-US" dirty="0"/>
@@ -1056,9 +1056,9 @@
           <a:p>
             <a:r>
               <a:rPr lang="en-US" dirty="0"/>
-              <a:t>OBJETIVO: Cerrar con una propuesta de acción clara.
-MENSAJE PRINCIPAL: El siguiente paso no depende de más presupuesto; depende de tener los materiales y el frente legal listos para lanzar con discreción.
-QUÉ EXPLICAR: Los tres pasos son secuenciales; el lanzamiento de la difusión debe esperar a que el teaser, la landing y el NDA estén listos.</a:t>
+              <a:t>OBJETIVO: Cerrar con una propuesta de acción clara sobre mi gestión digital.
+MENSAJE PRINCIPAL: El siguiente paso depende de tener listos los materiales digitales para lanzar con discreción.
+QUÉ EXPLICAR: Los tres pasos son secuenciales y están dentro del alcance de Meta Ads; el resto del proceso queda en manos de los propietarios.</a:t>
             </a:r>
             <a:endParaRPr lang="en-US" dirty="0"/>
           </a:p>
@@ -1147,8 +1147,8 @@
             <a:r>
               <a:rPr lang="en-US" dirty="0"/>
               <a:t>OBJETIVO: Establecer el punto de partida real.
-MENSAJE PRINCIPAL: El activo y su operación ya son sólidos (valor, facturación); lo que falta es un proceso comercial discreto para encontrar al comprador.
-QUÉ EXPLICAR: Hoy no hay ningún comprador calificado en proceso; se parte de cero en la búsqueda estructurada.</a:t>
+MENSAJE PRINCIPAL: El activo y su operación ya son sólidos; lo que falta es un canal digital que genere y filtre interesados.
+QUÉ EXPLICAR: Hoy no hay ningún interesado calificado en proceso; se parte de cero en la generación de leads.</a:t>
             </a:r>
             <a:endParaRPr lang="en-US" dirty="0"/>
           </a:p>
@@ -1236,9 +1236,9 @@
           <a:p>
             <a:r>
               <a:rPr lang="en-US" dirty="0"/>
-              <a:t>OBJETIVO: Explicar por qué este proceso es distinto a una venta inmobiliaria tradicional.
-MENSAJE PRINCIPAL: Hosty56 no es propiedad horizontal, así que debe venderse completo, a un único comprador con capacidad real.
-QUÉ EXPLICAR: Esta restricción define todo el enfoque: audiencia reducida, mensaje filtrado, información confidencial.</a:t>
+              <a:t>OBJETIVO: Explicar por qué la campaña digital debe ser discreta y muy filtrada.
+MENSAJE PRINCIPAL: Como Hosty56 solo puede venderse completo, el público útil es reducido; el resto son curiosos que hay que filtrar antes de que le quiten tiempo a los propietarios.
+QUÉ EXPLICAR: Esta restricción define todo el enfoque de la pauta: mensaje tipo teaser, filtro por formulario, sin exposición de datos sensibles.</a:t>
             </a:r>
             <a:endParaRPr lang="en-US" dirty="0"/>
           </a:p>
@@ -1326,9 +1326,9 @@
           <a:p>
             <a:r>
               <a:rPr lang="en-US" dirty="0"/>
-              <a:t>OBJETIVO: Presentar el activo con cifras concretas.
+              <a:t>OBJETIVO: Presentar el activo con cifras concretas, base de todo el mensaje de la campaña.
 MENSAJE PRINCIPAL: Hosty56 es un edificio ya en operación y generando ingresos, no un proyecto especulativo.
-QUÉ EXPLICAR: El yield bruto (~12% anual) es un buen ancla para el interés del comprador, pero debe presentarse siempre como cifra bruta, no como rentabilidad neta.</a:t>
+QUÉ EXPLICAR: El yield bruto (~12% anual) es un buen ancla para el interés, pero debe presentarse siempre como cifra bruta.</a:t>
             </a:r>
             <a:endParaRPr lang="en-US" dirty="0"/>
           </a:p>
@@ -1416,9 +1416,9 @@
           <a:p>
             <a:r>
               <a:rPr lang="en-US" dirty="0"/>
-              <a:t>OBJETIVO: Presentar la metodología completa en una sola imagen.
-MENSAJE PRINCIPAL: Cada etapa filtra al público y prepara la siguiente; el objetivo no es alcance, es precisión.
-QUÉ EXPLICAR: Difusión discreta (teaser sin datos sensibles), Calificación (NDA + dossier), Llamada de interés (screening), Visita y negociación (solo calificados).</a:t>
+              <a:t>OBJETIVO: Delimitar con total claridad el alcance de mi gestión frente al de los propietarios.
+MENSAJE PRINCIPAL: Yo genero, califico y entrego interesados reales vía Meta Ads. A partir de ahí, los propietarios manejan NDA, llamadas, visitas, negociación y cierre directamente.
+QUÉ EXPLICAR: Esta diapositiva evita cualquier expectativa de que yo participo en la negociación o el cierre — mi responsabilidad termina en la entrega del contacto calificado.</a:t>
             </a:r>
             <a:endParaRPr lang="en-US" dirty="0"/>
           </a:p>
@@ -1506,9 +1506,9 @@
           <a:p>
             <a:r>
               <a:rPr lang="en-US" dirty="0"/>
-              <a:t>OBJETIVO DE LA ETAPA: Generar interés real sin exponer información sensible del activo.
-MENSAJE PRINCIPAL: El anuncio vende la oportunidad, no el edificio; los datos exactos se entregan después del filtro.
-QUÉ EXPLICAR: El teaser nunca incluye dirección exacta, fotos identificables ni estados financieros detallados.</a:t>
+              <a:t>OBJETIVO: Presentar la metodología digital completa en una sola imagen.
+MENSAJE PRINCIPAL: Difusión discreta, calificación digital, y entrega — mi gestión termina en la tercera etapa.
+QUÉ EXPLICAR: Cada etapa se detalla en las siguientes diapositivas.</a:t>
             </a:r>
             <a:endParaRPr lang="en-US" dirty="0"/>
           </a:p>
@@ -1596,9 +1596,9 @@
           <a:p>
             <a:r>
               <a:rPr lang="en-US" dirty="0"/>
-              <a:t>OBJETIVO DE LA ETAPA: Separar interesados reales de curiosos antes de invertir tiempo en ellos.
-MENSAJE PRINCIPAL: Nadie ve la dirección ni las cifras completas sin antes calificar y firmar NDA.
-QUÉ EXPLICAR: Esta etapa es el filtro más importante contra 'preguntones'.</a:t>
+              <a:t>OBJETIVO DE LA ETAPA: Generar interés real sin exponer información sensible del activo.
+MENSAJE PRINCIPAL: El anuncio vende la oportunidad, no el edificio; los datos exactos nunca aparecen en el anuncio.
+QUÉ EXPLICAR: El teaser nunca incluye dirección exacta, fotos identificables ni estados financieros detallados.</a:t>
             </a:r>
             <a:endParaRPr lang="en-US" dirty="0"/>
           </a:p>
@@ -1686,9 +1686,9 @@
           <a:p>
             <a:r>
               <a:rPr lang="en-US" dirty="0"/>
-              <a:t>OBJETIVO DE LA ETAPA: Evitar visitas de curiosos protegiendo el tiempo de los propietarios.
-MENSAJE PRINCIPAL: La llamada confirma que quien visita el edificio tiene capacidad real de cerrar.
-QUÉ EXPLICAR: El guion de la llamada debe estar documentado en el plan operativo detallado.</a:t>
+              <a:t>OBJETIVO DE LA ETAPA: Separar interesados reales de curiosos por medios digitales, sin intervención manual.
+MENSAJE PRINCIPAL: El formulario hace el trabajo pesado de filtrar antes de que un contacto llegue a los propietarios.
+QUÉ EXPLICAR: Las preguntas exactas del formulario están documentadas en el plan operativo detallado.</a:t>
             </a:r>
             <a:endParaRPr lang="en-US" dirty="0"/>
           </a:p>
@@ -1776,9 +1776,9 @@
           <a:p>
             <a:r>
               <a:rPr lang="en-US" dirty="0"/>
-              <a:t>OBJETIVO DE LA ETAPA: Cerrar con el comprador correcto, con acompañamiento legal desde el inicio.
-MENSAJE PRINCIPAL: La visita es un privilegio reservado a quien ya demostró capacidad e interés real.
-QUÉ EXPLICAR: En esta etapa se coordina con el abogado de los propietarios la estructura final de venta.</a:t>
+              <a:t>OBJETIVO DE LA ETAPA: Formalizar el punto de traspaso entre mi gestión digital y la gestión directa de los propietarios.
+MENSAJE PRINCIPAL: Aquí termina mi responsabilidad operativa; el proceso de negociación y cierre es autónomo de los propietarios.
+QUÉ EXPLICAR: Se recomienda un formato simple y consistente de entrega (planilla o mensaje directo) para que el traspaso sea ordenado.</a:t>
             </a:r>
             <a:endParaRPr lang="en-US" dirty="0"/>
           </a:p>
@@ -2228,7 +2228,7 @@
                 <a:ea typeface="Calibri" pitchFamily="34" charset="-122"/>
                 <a:cs typeface="Calibri" pitchFamily="34" charset="-120"/>
               </a:rPr>
-              <a:t>PLAN DE VENTA · ACTIVO INMOBILIARIO · 2026</a:t>
+              <a:t>PLAN DE GESTIÓN DIGITAL · META ADS · 2026</a:t>
             </a:r>
             <a:endParaRPr lang="en-US" sz="1400" dirty="0"/>
           </a:p>
@@ -2282,7 +2282,7 @@
         <p:spPr>
           <a:xfrm>
             <a:off x="822960" y="3794760"/>
-            <a:ext cx="9601200" cy="548640"/>
+            <a:ext cx="9875520" cy="548640"/>
           </a:xfrm>
           <a:prstGeom prst="rect">
             <a:avLst/>
@@ -2306,7 +2306,7 @@
                 <a:ea typeface="Calibri" pitchFamily="34" charset="-122"/>
                 <a:cs typeface="Calibri" pitchFamily="34" charset="-120"/>
               </a:rPr>
-              <a:t>De un edificio en operación a un comprador único</a:t>
+              <a:t>Encontrar y filtrar interesados calificados para un edificio en venta</a:t>
             </a:r>
             <a:endParaRPr lang="en-US" sz="2000" dirty="0"/>
           </a:p>
@@ -2416,7 +2416,7 @@
                 <a:ea typeface="Calibri" pitchFamily="34" charset="-122"/>
                 <a:cs typeface="Calibri" pitchFamily="34" charset="-120"/>
               </a:rPr>
-              <a:t>PERFIL DE COMPRADOR</a:t>
+              <a:t>SEGMENTACIÓN DE CAMPAÑA</a:t>
             </a:r>
             <a:endParaRPr lang="en-US" sz="1300" dirty="0"/>
           </a:p>
@@ -2447,7 +2447,7 @@
               <a:buNone/>
             </a:pPr>
             <a:r>
-              <a:rPr lang="en-US" sz="3200" b="1" dirty="0">
+              <a:rPr lang="en-US" sz="3000" b="1" dirty="0">
                 <a:solidFill>
                   <a:srgbClr val="1C1F26"/>
                 </a:solidFill>
@@ -2457,7 +2457,7 @@
               </a:rPr>
               <a:t>Cualquier perfil con capacidad de compra total</a:t>
             </a:r>
-            <a:endParaRPr lang="en-US" sz="3200" dirty="0"/>
+            <a:endParaRPr lang="en-US" sz="3000" dirty="0"/>
           </a:p>
         </p:txBody>
       </p:sp>
@@ -2494,7 +2494,7 @@
                 <a:ea typeface="Calibri" pitchFamily="34" charset="-122"/>
                 <a:cs typeface="Calibri" pitchFamily="34" charset="-120"/>
               </a:rPr>
-              <a:t>El objetivo es un único comprador; el filtro es la capacidad, no el tipo.</a:t>
+              <a:t>La pauta se dirige a estos cinco perfiles simultáneamente.</a:t>
             </a:r>
             <a:endParaRPr lang="en-US" sz="1600" dirty="0"/>
           </a:p>
@@ -3173,7 +3173,7 @@
                 <a:ea typeface="Calibri" pitchFamily="34" charset="-122"/>
                 <a:cs typeface="Calibri" pitchFamily="34" charset="-120"/>
               </a:rPr>
-              <a:t>CONSIDERACIÓN LEGAL</a:t>
+              <a:t>FUERA DE MI ALCANCE</a:t>
             </a:r>
             <a:endParaRPr lang="en-US" sz="1400" dirty="0"/>
           </a:p>
@@ -3212,7 +3212,7 @@
                 <a:ea typeface="Cambria" pitchFamily="34" charset="-122"/>
                 <a:cs typeface="Cambria" pitchFamily="34" charset="-120"/>
               </a:rPr>
-              <a:t>Dos frentes que deben avanzar en paralelo a la campaña</a:t>
+              <a:t>Lo que los propietarios gestionan directamente</a:t>
             </a:r>
             <a:endParaRPr lang="en-US" sz="2400" dirty="0"/>
           </a:p>
@@ -3226,8 +3226,8 @@
         </p:nvSpPr>
         <p:spPr>
           <a:xfrm>
-            <a:off x="822960" y="2103120"/>
-            <a:ext cx="45720" cy="1371600"/>
+            <a:off x="822960" y="2203704"/>
+            <a:ext cx="45720" cy="502920"/>
           </a:xfrm>
           <a:prstGeom prst="rect">
             <a:avLst/>
@@ -3246,63 +3246,24 @@
         </p:nvSpPr>
         <p:spPr>
           <a:xfrm>
-            <a:off x="1051560" y="2057400"/>
-            <a:ext cx="9601200" cy="411480"/>
-          </a:xfrm>
-          <a:prstGeom prst="rect">
-            <a:avLst/>
-          </a:prstGeom>
-          <a:noFill/>
-          <a:ln/>
-        </p:spPr>
-        <p:txBody>
-          <a:bodyPr wrap="square" lIns="0" tIns="0" rIns="0" bIns="0" rtlCol="0" anchor="ctr"/>
-          <a:lstStyle/>
-          <a:p>
-            <a:pPr indent="0" marL="0">
-              <a:buNone/>
-            </a:pPr>
-            <a:r>
-              <a:rPr lang="en-US" sz="1800" b="1" dirty="0">
-                <a:solidFill>
-                  <a:srgbClr val="FFFFFF"/>
-                </a:solidFill>
-                <a:latin typeface="Calibri" pitchFamily="34" charset="0"/>
-                <a:ea typeface="Calibri" pitchFamily="34" charset="-122"/>
-                <a:cs typeface="Calibri" pitchFamily="34" charset="-120"/>
-              </a:rPr>
-              <a:t>Hipoteca vigente</a:t>
-            </a:r>
-            <a:endParaRPr lang="en-US" sz="1800" dirty="0"/>
-          </a:p>
-        </p:txBody>
-      </p:sp>
-      <p:sp>
-        <p:nvSpPr>
-          <p:cNvPr id="8" name="Text 5"/>
-          <p:cNvSpPr/>
-          <p:nvPr/>
-        </p:nvSpPr>
-        <p:spPr>
-          <a:xfrm>
-            <a:off x="1051560" y="2468880"/>
-            <a:ext cx="9601200" cy="914400"/>
-          </a:xfrm>
-          <a:prstGeom prst="rect">
-            <a:avLst/>
-          </a:prstGeom>
-          <a:noFill/>
-          <a:ln/>
-        </p:spPr>
-        <p:txBody>
-          <a:bodyPr wrap="square" lIns="0" tIns="0" rIns="0" bIns="0" rtlCol="0" anchor="ctr"/>
-          <a:lstStyle/>
-          <a:p>
-            <a:pPr indent="0" marL="0">
-              <a:buNone/>
-            </a:pPr>
-            <a:r>
-              <a:rPr lang="en-US" sz="1350" dirty="0">
+            <a:off x="1051560" y="2148840"/>
+            <a:ext cx="9966960" cy="777240"/>
+          </a:xfrm>
+          <a:prstGeom prst="rect">
+            <a:avLst/>
+          </a:prstGeom>
+          <a:noFill/>
+          <a:ln/>
+        </p:spPr>
+        <p:txBody>
+          <a:bodyPr wrap="square" lIns="0" tIns="0" rIns="0" bIns="0" rtlCol="0" anchor="ctr"/>
+          <a:lstStyle/>
+          <a:p>
+            <a:pPr indent="0" marL="0">
+              <a:buNone/>
+            </a:pPr>
+            <a:r>
+              <a:rPr lang="en-US" sz="1400" dirty="0">
                 <a:solidFill>
                   <a:srgbClr val="C9CDD6"/>
                 </a:solidFill>
@@ -3310,22 +3271,22 @@
                 <a:ea typeface="Calibri" pitchFamily="34" charset="-122"/>
                 <a:cs typeface="Calibri" pitchFamily="34" charset="-120"/>
               </a:rPr>
-              <a:t>El inmueble tiene una hipoteca activa a nombre de la sociedad. Debe definirse con el comprador si se cancela antes del cierre o se asume como parte de la estructura de pago.</a:t>
-            </a:r>
-            <a:endParaRPr lang="en-US" sz="1350" dirty="0"/>
-          </a:p>
-        </p:txBody>
-      </p:sp>
-      <p:sp>
-        <p:nvSpPr>
-          <p:cNvPr id="9" name="Shape 6"/>
-          <p:cNvSpPr/>
-          <p:nvPr/>
-        </p:nvSpPr>
-        <p:spPr>
-          <a:xfrm>
-            <a:off x="822960" y="3794760"/>
-            <a:ext cx="45720" cy="1371600"/>
+              <a:t>NDA y entrega del dossier confidencial (dirección, fotos, estados financieros)</a:t>
+            </a:r>
+            <a:endParaRPr lang="en-US" sz="1400" dirty="0"/>
+          </a:p>
+        </p:txBody>
+      </p:sp>
+      <p:sp>
+        <p:nvSpPr>
+          <p:cNvPr id="8" name="Shape 5"/>
+          <p:cNvSpPr/>
+          <p:nvPr/>
+        </p:nvSpPr>
+        <p:spPr>
+          <a:xfrm>
+            <a:off x="822960" y="3118104"/>
+            <a:ext cx="45720" cy="502920"/>
           </a:xfrm>
           <a:prstGeom prst="rect">
             <a:avLst/>
@@ -3338,42 +3299,62 @@
       </p:sp>
       <p:sp>
         <p:nvSpPr>
-          <p:cNvPr id="10" name="Text 7"/>
-          <p:cNvSpPr/>
-          <p:nvPr/>
-        </p:nvSpPr>
-        <p:spPr>
-          <a:xfrm>
-            <a:off x="1051560" y="3749040"/>
-            <a:ext cx="9601200" cy="411480"/>
-          </a:xfrm>
-          <a:prstGeom prst="rect">
-            <a:avLst/>
-          </a:prstGeom>
-          <a:noFill/>
-          <a:ln/>
-        </p:spPr>
-        <p:txBody>
-          <a:bodyPr wrap="square" lIns="0" tIns="0" rIns="0" bIns="0" rtlCol="0" anchor="ctr"/>
-          <a:lstStyle/>
-          <a:p>
-            <a:pPr indent="0" marL="0">
-              <a:buNone/>
-            </a:pPr>
-            <a:r>
-              <a:rPr lang="en-US" sz="1800" b="1" dirty="0">
-                <a:solidFill>
-                  <a:srgbClr val="FFFFFF"/>
-                </a:solidFill>
-                <a:latin typeface="Calibri" pitchFamily="34" charset="0"/>
-                <a:ea typeface="Calibri" pitchFamily="34" charset="-122"/>
-                <a:cs typeface="Calibri" pitchFamily="34" charset="-120"/>
-              </a:rPr>
-              <a:t>Proceso de sucesión</a:t>
-            </a:r>
-            <a:endParaRPr lang="en-US" sz="1800" dirty="0"/>
-          </a:p>
-        </p:txBody>
+          <p:cNvPr id="9" name="Text 6"/>
+          <p:cNvSpPr/>
+          <p:nvPr/>
+        </p:nvSpPr>
+        <p:spPr>
+          <a:xfrm>
+            <a:off x="1051560" y="3063240"/>
+            <a:ext cx="9966960" cy="777240"/>
+          </a:xfrm>
+          <a:prstGeom prst="rect">
+            <a:avLst/>
+          </a:prstGeom>
+          <a:noFill/>
+          <a:ln/>
+        </p:spPr>
+        <p:txBody>
+          <a:bodyPr wrap="square" lIns="0" tIns="0" rIns="0" bIns="0" rtlCol="0" anchor="ctr"/>
+          <a:lstStyle/>
+          <a:p>
+            <a:pPr indent="0" marL="0">
+              <a:buNone/>
+            </a:pPr>
+            <a:r>
+              <a:rPr lang="en-US" sz="1400" dirty="0">
+                <a:solidFill>
+                  <a:srgbClr val="C9CDD6"/>
+                </a:solidFill>
+                <a:latin typeface="Calibri" pitchFamily="34" charset="0"/>
+                <a:ea typeface="Calibri" pitchFamily="34" charset="-122"/>
+                <a:cs typeface="Calibri" pitchFamily="34" charset="-120"/>
+              </a:rPr>
+              <a:t>Llamadas de verificación y visitas presenciales al edificio</a:t>
+            </a:r>
+            <a:endParaRPr lang="en-US" sz="1400" dirty="0"/>
+          </a:p>
+        </p:txBody>
+      </p:sp>
+      <p:sp>
+        <p:nvSpPr>
+          <p:cNvPr id="10" name="Shape 7"/>
+          <p:cNvSpPr/>
+          <p:nvPr/>
+        </p:nvSpPr>
+        <p:spPr>
+          <a:xfrm>
+            <a:off x="822960" y="4032504"/>
+            <a:ext cx="45720" cy="502920"/>
+          </a:xfrm>
+          <a:prstGeom prst="rect">
+            <a:avLst/>
+          </a:prstGeom>
+          <a:solidFill>
+            <a:srgbClr val="B08D57"/>
+          </a:solidFill>
+          <a:ln/>
+        </p:spPr>
       </p:sp>
       <p:sp>
         <p:nvSpPr>
@@ -3383,24 +3364,24 @@
         </p:nvSpPr>
         <p:spPr>
           <a:xfrm>
-            <a:off x="1051560" y="4160520"/>
-            <a:ext cx="9601200" cy="914400"/>
-          </a:xfrm>
-          <a:prstGeom prst="rect">
-            <a:avLst/>
-          </a:prstGeom>
-          <a:noFill/>
-          <a:ln/>
-        </p:spPr>
-        <p:txBody>
-          <a:bodyPr wrap="square" lIns="0" tIns="0" rIns="0" bIns="0" rtlCol="0" anchor="ctr"/>
-          <a:lstStyle/>
-          <a:p>
-            <a:pPr indent="0" marL="0">
-              <a:buNone/>
-            </a:pPr>
-            <a:r>
-              <a:rPr lang="en-US" sz="1350" dirty="0">
+            <a:off x="1051560" y="3977640"/>
+            <a:ext cx="9966960" cy="777240"/>
+          </a:xfrm>
+          <a:prstGeom prst="rect">
+            <a:avLst/>
+          </a:prstGeom>
+          <a:noFill/>
+          <a:ln/>
+        </p:spPr>
+        <p:txBody>
+          <a:bodyPr wrap="square" lIns="0" tIns="0" rIns="0" bIns="0" rtlCol="0" anchor="ctr"/>
+          <a:lstStyle/>
+          <a:p>
+            <a:pPr indent="0" marL="0">
+              <a:buNone/>
+            </a:pPr>
+            <a:r>
+              <a:rPr lang="en-US" sz="1400" dirty="0">
                 <a:solidFill>
                   <a:srgbClr val="C9CDD6"/>
                 </a:solidFill>
@@ -3408,38 +3389,97 @@
                 <a:ea typeface="Calibri" pitchFamily="34" charset="-122"/>
                 <a:cs typeface="Calibri" pitchFamily="34" charset="-120"/>
               </a:rPr>
-              <a:t>Un porcentaje de la participación societaria (no la totalidad) está sujeto a un proceso de sucesión en curso. Su avance debe confirmarse con el abogado de los propietarios.</a:t>
-            </a:r>
-            <a:endParaRPr lang="en-US" sz="1350" dirty="0"/>
-          </a:p>
-        </p:txBody>
-      </p:sp>
-      <p:sp>
-        <p:nvSpPr>
-          <p:cNvPr id="12" name="Text 9"/>
-          <p:cNvSpPr/>
-          <p:nvPr/>
-        </p:nvSpPr>
-        <p:spPr>
-          <a:xfrm>
-            <a:off x="822960" y="5669280"/>
-            <a:ext cx="10332720" cy="640080"/>
-          </a:xfrm>
-          <a:prstGeom prst="rect">
-            <a:avLst/>
-          </a:prstGeom>
-          <a:noFill/>
-          <a:ln/>
-        </p:spPr>
-        <p:txBody>
-          <a:bodyPr wrap="square" lIns="0" tIns="0" rIns="0" bIns="0" rtlCol="0" anchor="ctr"/>
-          <a:lstStyle/>
-          <a:p>
-            <a:pPr indent="0" marL="0">
-              <a:buNone/>
-            </a:pPr>
-            <a:r>
-              <a:rPr lang="en-US" sz="1300" i="1" dirty="0">
+              <a:t>Negociación, estructura de la oferta y cierre de la venta</a:t>
+            </a:r>
+            <a:endParaRPr lang="en-US" sz="1400" dirty="0"/>
+          </a:p>
+        </p:txBody>
+      </p:sp>
+      <p:sp>
+        <p:nvSpPr>
+          <p:cNvPr id="12" name="Shape 9"/>
+          <p:cNvSpPr/>
+          <p:nvPr/>
+        </p:nvSpPr>
+        <p:spPr>
+          <a:xfrm>
+            <a:off x="822960" y="4946904"/>
+            <a:ext cx="45720" cy="502920"/>
+          </a:xfrm>
+          <a:prstGeom prst="rect">
+            <a:avLst/>
+          </a:prstGeom>
+          <a:solidFill>
+            <a:srgbClr val="B08D57"/>
+          </a:solidFill>
+          <a:ln/>
+        </p:spPr>
+      </p:sp>
+      <p:sp>
+        <p:nvSpPr>
+          <p:cNvPr id="13" name="Text 10"/>
+          <p:cNvSpPr/>
+          <p:nvPr/>
+        </p:nvSpPr>
+        <p:spPr>
+          <a:xfrm>
+            <a:off x="1051560" y="4892040"/>
+            <a:ext cx="9966960" cy="777240"/>
+          </a:xfrm>
+          <a:prstGeom prst="rect">
+            <a:avLst/>
+          </a:prstGeom>
+          <a:noFill/>
+          <a:ln/>
+        </p:spPr>
+        <p:txBody>
+          <a:bodyPr wrap="square" lIns="0" tIns="0" rIns="0" bIns="0" rtlCol="0" anchor="ctr"/>
+          <a:lstStyle/>
+          <a:p>
+            <a:pPr indent="0" marL="0">
+              <a:buNone/>
+            </a:pPr>
+            <a:r>
+              <a:rPr lang="en-US" sz="1400" dirty="0">
+                <a:solidFill>
+                  <a:srgbClr val="C9CDD6"/>
+                </a:solidFill>
+                <a:latin typeface="Calibri" pitchFamily="34" charset="0"/>
+                <a:ea typeface="Calibri" pitchFamily="34" charset="-122"/>
+                <a:cs typeface="Calibri" pitchFamily="34" charset="-120"/>
+              </a:rPr>
+              <a:t>Aspectos legales de la sociedad: existe una hipoteca vigente y un porcentaje de la participación societaria está en proceso de sucesión — se recomienda resolver esto con su abogado, en paralelo a la campaña</a:t>
+            </a:r>
+            <a:endParaRPr lang="en-US" sz="1400" dirty="0"/>
+          </a:p>
+        </p:txBody>
+      </p:sp>
+      <p:sp>
+        <p:nvSpPr>
+          <p:cNvPr id="14" name="Text 11"/>
+          <p:cNvSpPr/>
+          <p:nvPr/>
+        </p:nvSpPr>
+        <p:spPr>
+          <a:xfrm>
+            <a:off x="822960" y="5943600"/>
+            <a:ext cx="10332720" cy="548640"/>
+          </a:xfrm>
+          <a:prstGeom prst="rect">
+            <a:avLst/>
+          </a:prstGeom>
+          <a:noFill/>
+          <a:ln/>
+        </p:spPr>
+        <p:txBody>
+          <a:bodyPr wrap="square" lIns="0" tIns="0" rIns="0" bIns="0" rtlCol="0" anchor="ctr"/>
+          <a:lstStyle/>
+          <a:p>
+            <a:pPr indent="0" marL="0">
+              <a:buNone/>
+            </a:pPr>
+            <a:r>
+              <a:rPr lang="en-US" sz="1250" i="1" dirty="0">
                 <a:solidFill>
                   <a:srgbClr val="B08D57"/>
                 </a:solidFill>
@@ -3447,15 +3487,15 @@
                 <a:ea typeface="Calibri" pitchFamily="34" charset="-122"/>
                 <a:cs typeface="Calibri" pitchFamily="34" charset="-120"/>
               </a:rPr>
-              <a:t>Recomendación: avanzar la claridad legal en paralelo a la difusión comercial. Esta información se comparte solo bajo NDA — nunca en el teaser público.</a:t>
-            </a:r>
-            <a:endParaRPr lang="en-US" sz="1300" dirty="0"/>
-          </a:p>
-        </p:txBody>
-      </p:sp>
-      <p:sp>
-        <p:nvSpPr>
-          <p:cNvPr id="13" name="Text 10"/>
+              <a:t>Esta información nunca se menciona en el teaser público de Meta Ads; solo la comparten los propietarios en su propio proceso.</a:t>
+            </a:r>
+            <a:endParaRPr lang="en-US" sz="1250" dirty="0"/>
+          </a:p>
+        </p:txBody>
+      </p:sp>
+      <p:sp>
+        <p:nvSpPr>
+          <p:cNvPr id="15" name="Text 12"/>
           <p:cNvSpPr/>
           <p:nvPr/>
         </p:nvSpPr>
@@ -3588,7 +3628,7 @@
               <a:buNone/>
             </a:pPr>
             <a:r>
-              <a:rPr lang="en-US" sz="3200" b="1" dirty="0">
+              <a:rPr lang="en-US" sz="3000" b="1" dirty="0">
                 <a:solidFill>
                   <a:srgbClr val="1C1F26"/>
                 </a:solidFill>
@@ -3596,9 +3636,9 @@
                 <a:ea typeface="Cambria" pitchFamily="34" charset="-122"/>
                 <a:cs typeface="Cambria" pitchFamily="34" charset="-120"/>
               </a:rPr>
-              <a:t>Los primeros 3 meses, mes a mes</a:t>
-            </a:r>
-            <a:endParaRPr lang="en-US" sz="3200" dirty="0"/>
+              <a:t>Los primeros 3 meses de campaña, mes a mes</a:t>
+            </a:r>
+            <a:endParaRPr lang="en-US" sz="3000" dirty="0"/>
           </a:p>
         </p:txBody>
       </p:sp>
@@ -3718,7 +3758,7 @@
                 <a:ea typeface="Calibri" pitchFamily="34" charset="-122"/>
                 <a:cs typeface="Calibri" pitchFamily="34" charset="-120"/>
               </a:rPr>
-              <a:t>Preparación y difusión</a:t>
+              <a:t>Preparación y lanzamiento</a:t>
             </a:r>
             <a:endParaRPr lang="en-US" sz="1550" dirty="0"/>
           </a:p>
@@ -3761,7 +3801,7 @@
                 <a:ea typeface="Calibri" pitchFamily="34" charset="-122"/>
                 <a:cs typeface="Calibri" pitchFamily="34" charset="-120"/>
               </a:rPr>
-              <a:t>Teaser, landing, NDA y dossier confidencial listos</a:t>
+              <a:t>Teaser, landing y formulario de calificación listos</a:t>
             </a:r>
             <a:endParaRPr lang="en-US" sz="1250" dirty="0"/>
           </a:p>
@@ -3803,7 +3843,7 @@
                 <a:ea typeface="Calibri" pitchFamily="34" charset="-122"/>
                 <a:cs typeface="Calibri" pitchFamily="34" charset="-120"/>
               </a:rPr>
-              <a:t>Primeras llamadas de calificación</a:t>
+              <a:t>Primeras entregas de interesados calificados</a:t>
             </a:r>
             <a:endParaRPr lang="en-US" sz="1250" dirty="0"/>
           </a:p>
@@ -3831,7 +3871,7 @@
       </p:sp>
       <p:pic>
         <p:nvPicPr>
-          <p:cNvPr id="10" name="Image 1" descr="/tmp/hosty56_build/icons/fileSignature_gold.png">    </p:cNvPr>
+          <p:cNvPr id="10" name="Image 1" descr="/tmp/hosty56_build/icons/filter_gold.png">    </p:cNvPr>
           <p:cNvPicPr>
             <a:picLocks noChangeAspect="1"/>
           </p:cNvPicPr>
@@ -3925,7 +3965,7 @@
                 <a:ea typeface="Calibri" pitchFamily="34" charset="-122"/>
                 <a:cs typeface="Calibri" pitchFamily="34" charset="-120"/>
               </a:rPr>
-              <a:t>Calificación activa</a:t>
+              <a:t>Optimización</a:t>
             </a:r>
             <a:endParaRPr lang="en-US" sz="1550" dirty="0"/>
           </a:p>
@@ -3968,7 +4008,7 @@
                 <a:ea typeface="Calibri" pitchFamily="34" charset="-122"/>
                 <a:cs typeface="Calibri" pitchFamily="34" charset="-120"/>
               </a:rPr>
-              <a:t>Optimización de segmentación según quién califica mejor</a:t>
+              <a:t>Ajuste de audiencias y creativos según quién califica mejor</a:t>
             </a:r>
             <a:endParaRPr lang="en-US" sz="1250" dirty="0"/>
           </a:p>
@@ -3989,7 +4029,7 @@
                 <a:ea typeface="Calibri" pitchFamily="34" charset="-122"/>
                 <a:cs typeface="Calibri" pitchFamily="34" charset="-120"/>
               </a:rPr>
-              <a:t>Primeras visitas con interesados serios</a:t>
+              <a:t>Se descartan los segmentos que solo generan curiosos</a:t>
             </a:r>
             <a:endParaRPr lang="en-US" sz="1250" dirty="0"/>
           </a:p>
@@ -4010,7 +4050,7 @@
                 <a:ea typeface="Calibri" pitchFamily="34" charset="-122"/>
                 <a:cs typeface="Calibri" pitchFamily="34" charset="-120"/>
               </a:rPr>
-              <a:t>Inicio de conversaciones de estructura de negociación</a:t>
+              <a:t>Aumento gradual del volumen de interesados calificados</a:t>
             </a:r>
             <a:endParaRPr lang="en-US" sz="1250" dirty="0"/>
           </a:p>
@@ -4038,7 +4078,7 @@
       </p:sp>
       <p:pic>
         <p:nvPicPr>
-          <p:cNvPr id="15" name="Image 2" descr="/tmp/hosty56_build/icons/handshake_gold.png">    </p:cNvPr>
+          <p:cNvPr id="15" name="Image 2" descr="/tmp/hosty56_build/icons/arrowRight_gold.png">    </p:cNvPr>
           <p:cNvPicPr>
             <a:picLocks noChangeAspect="1"/>
           </p:cNvPicPr>
@@ -4132,7 +4172,7 @@
                 <a:ea typeface="Calibri" pitchFamily="34" charset="-122"/>
                 <a:cs typeface="Calibri" pitchFamily="34" charset="-120"/>
               </a:rPr>
-              <a:t>Negociación y cierre</a:t>
+              <a:t>Escalamiento</a:t>
             </a:r>
             <a:endParaRPr lang="en-US" sz="1550" dirty="0"/>
           </a:p>
@@ -4175,7 +4215,7 @@
                 <a:ea typeface="Calibri" pitchFamily="34" charset="-122"/>
                 <a:cs typeface="Calibri" pitchFamily="34" charset="-120"/>
               </a:rPr>
-              <a:t>Remarketing sobre quienes ya vieron el dossier</a:t>
+              <a:t>Escalamiento de presupuesto en las audiencias de mejor desempeño</a:t>
             </a:r>
             <a:endParaRPr lang="en-US" sz="1250" dirty="0"/>
           </a:p>
@@ -4196,7 +4236,7 @@
                 <a:ea typeface="Calibri" pitchFamily="34" charset="-122"/>
                 <a:cs typeface="Calibri" pitchFamily="34" charset="-120"/>
               </a:rPr>
-              <a:t>Acompañamiento a la negociación más avanzada</a:t>
+              <a:t>Remarketing sobre quienes interactuaron sin calificar aún</a:t>
             </a:r>
             <a:endParaRPr lang="en-US" sz="1250" dirty="0"/>
           </a:p>
@@ -4217,7 +4257,7 @@
                 <a:ea typeface="Calibri" pitchFamily="34" charset="-122"/>
                 <a:cs typeface="Calibri" pitchFamily="34" charset="-120"/>
               </a:rPr>
-              <a:t>Avance legal (hipoteca/sucesión) como respaldo de cierre</a:t>
+              <a:t>Entrega continua de interesados a los propietarios</a:t>
             </a:r>
             <a:endParaRPr lang="en-US" sz="1250" dirty="0"/>
           </a:p>
@@ -4358,7 +4398,7 @@
               <a:buNone/>
             </a:pPr>
             <a:r>
-              <a:rPr lang="en-US" sz="3200" b="1" dirty="0">
+              <a:rPr lang="en-US" sz="3000" b="1" dirty="0">
                 <a:solidFill>
                   <a:srgbClr val="1C1F26"/>
                 </a:solidFill>
@@ -4368,7 +4408,7 @@
               </a:rPr>
               <a:t>Cronograma semana a semana</a:t>
             </a:r>
-            <a:endParaRPr lang="en-US" sz="3200" dirty="0"/>
+            <a:endParaRPr lang="en-US" sz="3000" dirty="0"/>
           </a:p>
         </p:txBody>
       </p:sp>
@@ -4466,7 +4506,7 @@
                 <a:ea typeface="Calibri" pitchFamily="34" charset="-122"/>
                 <a:cs typeface="Calibri" pitchFamily="34" charset="-120"/>
               </a:rPr>
-              <a:t>Preparación de materiales (teaser, landing, NDA, dossier) y auditoría legal en paralelo</a:t>
+              <a:t>Preparación de teaser, landing y formulario de calificación</a:t>
             </a:r>
             <a:endParaRPr lang="en-US" sz="1200" dirty="0"/>
           </a:p>
@@ -4666,7 +4706,7 @@
                 <a:ea typeface="Calibri" pitchFamily="34" charset="-122"/>
                 <a:cs typeface="Calibri" pitchFamily="34" charset="-120"/>
               </a:rPr>
-              <a:t>Primeras calificaciones y llamadas de interés</a:t>
+              <a:t>Primeras entregas de interesados calificados a los propietarios</a:t>
             </a:r>
             <a:endParaRPr lang="en-US" sz="1200" dirty="0"/>
           </a:p>
@@ -4766,7 +4806,7 @@
                 <a:ea typeface="Calibri" pitchFamily="34" charset="-122"/>
                 <a:cs typeface="Calibri" pitchFamily="34" charset="-120"/>
               </a:rPr>
-              <a:t>Primeras visitas presenciales al edificio</a:t>
+              <a:t>Optimización de segmentación y creativos según resultados</a:t>
             </a:r>
             <a:endParaRPr lang="en-US" sz="1200" dirty="0"/>
           </a:p>
@@ -4866,7 +4906,7 @@
                 <a:ea typeface="Calibri" pitchFamily="34" charset="-122"/>
                 <a:cs typeface="Calibri" pitchFamily="34" charset="-120"/>
               </a:rPr>
-              <a:t>Negociaciones iniciales y remarketing sobre calificados</a:t>
+              <a:t>Escalamiento de presupuesto en las audiencias de mejor desempeño</a:t>
             </a:r>
             <a:endParaRPr lang="en-US" sz="1200" dirty="0"/>
           </a:p>
@@ -4966,7 +5006,7 @@
                 <a:ea typeface="Calibri" pitchFamily="34" charset="-122"/>
                 <a:cs typeface="Calibri" pitchFamily="34" charset="-120"/>
               </a:rPr>
-              <a:t>Cierre con el interesado más avanzado o evaluación de extender el plazo</a:t>
+              <a:t>Remarketing continuo y balance de resultados con los propietarios</a:t>
             </a:r>
             <a:endParaRPr lang="en-US" sz="1200" dirty="0"/>
           </a:p>
@@ -5107,7 +5147,7 @@
               <a:buNone/>
             </a:pPr>
             <a:r>
-              <a:rPr lang="en-US" sz="3200" b="1" dirty="0">
+              <a:rPr lang="en-US" sz="3000" b="1" dirty="0">
                 <a:solidFill>
                   <a:srgbClr val="1C1F26"/>
                 </a:solidFill>
@@ -5117,7 +5157,7 @@
               </a:rPr>
               <a:t>Dos componentes de honorarios, condiciones distintas</a:t>
             </a:r>
-            <a:endParaRPr lang="en-US" sz="3200" dirty="0"/>
+            <a:endParaRPr lang="en-US" sz="3000" dirty="0"/>
           </a:p>
         </p:txBody>
       </p:sp>
@@ -5176,7 +5216,7 @@
                 <a:ea typeface="Calibri" pitchFamily="34" charset="-122"/>
                 <a:cs typeface="Calibri" pitchFamily="34" charset="-120"/>
               </a:rPr>
-              <a:t>HONORARIOS DE GESTIÓN</a:t>
+              <a:t>HONORARIOS DE GESTIÓN DIGITAL</a:t>
             </a:r>
             <a:endParaRPr lang="en-US" sz="1300" dirty="0"/>
           </a:p>
@@ -5268,7 +5308,7 @@
                 <a:ea typeface="Calibri" pitchFamily="34" charset="-122"/>
                 <a:cs typeface="Calibri" pitchFamily="34" charset="-120"/>
               </a:rPr>
-              <a:t>Cubre la estrategia, la difusión, la calificación de interesados y la gestión operativa del proceso. Los propietarios asumen aparte el presupuesto de pauta en Meta Ads.</a:t>
+              <a:t>Cubre la estrategia, creación y optimización de campañas en Meta Ads para generar y filtrar interesados calificados. Los propietarios asumen aparte el presupuesto de pauta.</a:t>
             </a:r>
             <a:endParaRPr lang="en-US" sz="1300" dirty="0"/>
           </a:p>
@@ -5421,7 +5461,7 @@
                 <a:ea typeface="Calibri" pitchFamily="34" charset="-122"/>
                 <a:cs typeface="Calibri" pitchFamily="34" charset="-120"/>
               </a:rPr>
-              <a:t>Aplica únicamente si el comprador que cierra la compra es entregado directamente por esta gestión. Si el cierre se da por otro medio ajeno a esta campaña, no aplica.</a:t>
+              <a:t>Aplica únicamente si el comprador que cierra la compra es entregado directamente por esta gestión de Meta Ads. Si el cierre se da por otro medio, no aplica.</a:t>
             </a:r>
             <a:endParaRPr lang="en-US" sz="1300" dirty="0"/>
           </a:p>
@@ -5436,7 +5476,7 @@
         <p:spPr>
           <a:xfrm>
             <a:off x="640080" y="6291072"/>
-            <a:ext cx="10058400" cy="320040"/>
+            <a:ext cx="10607040" cy="320040"/>
           </a:xfrm>
           <a:prstGeom prst="rect">
             <a:avLst/>
@@ -5460,7 +5500,7 @@
                 <a:ea typeface="Calibri" pitchFamily="34" charset="-122"/>
                 <a:cs typeface="Calibri" pitchFamily="34" charset="-120"/>
               </a:rPr>
-              <a:t>Los honorarios cubren estrategia y gestión; la comisión de éxito reconoce específicamente la entrega directa del comprador que cierra la operación.</a:t>
+              <a:t>El fijo remunera la gestión digital; la comisión de éxito reconoce específicamente la entrega directa del comprador que cierra.</a:t>
             </a:r>
             <a:endParaRPr lang="en-US" sz="1050" dirty="0"/>
           </a:p>
@@ -5585,7 +5625,7 @@
         <p:spPr>
           <a:xfrm>
             <a:off x="822960" y="1234440"/>
-            <a:ext cx="10058400" cy="1371600"/>
+            <a:ext cx="10332720" cy="1371600"/>
           </a:xfrm>
           <a:prstGeom prst="rect">
             <a:avLst/>
@@ -5626,7 +5666,7 @@
                 <a:ea typeface="Cambria" pitchFamily="34" charset="-122"/>
                 <a:cs typeface="Cambria" pitchFamily="34" charset="-120"/>
               </a:rPr>
-              <a:t>Es un proceso de venta discreto y filtrado.</a:t>
+              <a:t>Es un canal digital que filtra antes de entregar.</a:t>
             </a:r>
             <a:endParaRPr lang="en-US" sz="3000" dirty="0"/>
           </a:p>
@@ -5700,7 +5740,7 @@
         <p:spPr>
           <a:xfrm>
             <a:off x="1508760" y="3246120"/>
-            <a:ext cx="9144000" cy="365760"/>
+            <a:ext cx="9418320" cy="365760"/>
           </a:xfrm>
           <a:prstGeom prst="rect">
             <a:avLst/>
@@ -5739,7 +5779,7 @@
         <p:spPr>
           <a:xfrm>
             <a:off x="1508760" y="3611880"/>
-            <a:ext cx="9144000" cy="365760"/>
+            <a:ext cx="9418320" cy="365760"/>
           </a:xfrm>
           <a:prstGeom prst="rect">
             <a:avLst/>
@@ -5763,7 +5803,7 @@
                 <a:ea typeface="Calibri" pitchFamily="34" charset="-122"/>
                 <a:cs typeface="Calibri" pitchFamily="34" charset="-120"/>
               </a:rPr>
-              <a:t>Teaser, landing, NDA y dossier confidencial</a:t>
+              <a:t>Teaser, landing y formulario de calificación</a:t>
             </a:r>
             <a:endParaRPr lang="en-US" sz="1300" dirty="0"/>
           </a:p>
@@ -5837,7 +5877,7 @@
         <p:spPr>
           <a:xfrm>
             <a:off x="1508760" y="4114800"/>
-            <a:ext cx="9144000" cy="365760"/>
+            <a:ext cx="9418320" cy="365760"/>
           </a:xfrm>
           <a:prstGeom prst="rect">
             <a:avLst/>
@@ -5861,7 +5901,7 @@
                 <a:ea typeface="Calibri" pitchFamily="34" charset="-122"/>
                 <a:cs typeface="Calibri" pitchFamily="34" charset="-120"/>
               </a:rPr>
-              <a:t>Avanzar el frente legal</a:t>
+              <a:t>Lanzar la difusión</a:t>
             </a:r>
             <a:endParaRPr lang="en-US" sz="1600" dirty="0"/>
           </a:p>
@@ -5876,7 +5916,7 @@
         <p:spPr>
           <a:xfrm>
             <a:off x="1508760" y="4480560"/>
-            <a:ext cx="9144000" cy="365760"/>
+            <a:ext cx="9418320" cy="365760"/>
           </a:xfrm>
           <a:prstGeom prst="rect">
             <a:avLst/>
@@ -5900,7 +5940,7 @@
                 <a:ea typeface="Calibri" pitchFamily="34" charset="-122"/>
                 <a:cs typeface="Calibri" pitchFamily="34" charset="-120"/>
               </a:rPr>
-              <a:t>Claridad sobre hipoteca y proceso de sucesión, en paralelo</a:t>
+              <a:t>Campaña discreta en Meta Ads, en Bogotá, dirigida a los cinco perfiles de comprador</a:t>
             </a:r>
             <a:endParaRPr lang="en-US" sz="1300" dirty="0"/>
           </a:p>
@@ -5974,7 +6014,7 @@
         <p:spPr>
           <a:xfrm>
             <a:off x="1508760" y="4983480"/>
-            <a:ext cx="9144000" cy="365760"/>
+            <a:ext cx="9418320" cy="365760"/>
           </a:xfrm>
           <a:prstGeom prst="rect">
             <a:avLst/>
@@ -5998,7 +6038,7 @@
                 <a:ea typeface="Calibri" pitchFamily="34" charset="-122"/>
                 <a:cs typeface="Calibri" pitchFamily="34" charset="-120"/>
               </a:rPr>
-              <a:t>Lanzar la difusión</a:t>
+              <a:t>Entregar interesados calificados</a:t>
             </a:r>
             <a:endParaRPr lang="en-US" sz="1600" dirty="0"/>
           </a:p>
@@ -6013,7 +6053,7 @@
         <p:spPr>
           <a:xfrm>
             <a:off x="1508760" y="5349240"/>
-            <a:ext cx="9144000" cy="365760"/>
+            <a:ext cx="9418320" cy="365760"/>
           </a:xfrm>
           <a:prstGeom prst="rect">
             <a:avLst/>
@@ -6037,7 +6077,7 @@
                 <a:ea typeface="Calibri" pitchFamily="34" charset="-122"/>
                 <a:cs typeface="Calibri" pitchFamily="34" charset="-120"/>
               </a:rPr>
-              <a:t>Campaña discreta en Meta Ads, en Bogotá, con miras a un comprador único</a:t>
+              <a:t>Traspaso ordenado a los propietarios, quienes continúan el proceso</a:t>
             </a:r>
             <a:endParaRPr lang="en-US" sz="1300" dirty="0"/>
           </a:p>
@@ -6178,7 +6218,7 @@
               <a:buNone/>
             </a:pPr>
             <a:r>
-              <a:rPr lang="en-US" sz="3200" b="1" dirty="0">
+              <a:rPr lang="en-US" sz="3000" b="1" dirty="0">
                 <a:solidFill>
                   <a:srgbClr val="1C1F26"/>
                 </a:solidFill>
@@ -6186,9 +6226,9 @@
                 <a:ea typeface="Cambria" pitchFamily="34" charset="-122"/>
                 <a:cs typeface="Cambria" pitchFamily="34" charset="-120"/>
               </a:rPr>
-              <a:t>Hoy, Hosty56 es un activo sólido sin comprador todavía.</a:t>
-            </a:r>
-            <a:endParaRPr lang="en-US" sz="3200" dirty="0"/>
+              <a:t>Hoy, Hosty56 es un activo sólido sin interesados calificados.</a:t>
+            </a:r>
+            <a:endParaRPr lang="en-US" sz="3000" dirty="0"/>
           </a:p>
         </p:txBody>
       </p:sp>
@@ -6552,7 +6592,7 @@
                 <a:ea typeface="Calibri" pitchFamily="34" charset="-122"/>
                 <a:cs typeface="Calibri" pitchFamily="34" charset="-120"/>
               </a:rPr>
-              <a:t>Compradores calificados en proceso hoy</a:t>
+              <a:t>Interesados calificados en proceso hoy</a:t>
             </a:r>
             <a:endParaRPr lang="en-US" sz="1350" dirty="0"/>
           </a:p>
@@ -6567,7 +6607,7 @@
         <p:spPr>
           <a:xfrm>
             <a:off x="640080" y="4846320"/>
-            <a:ext cx="10515600" cy="731520"/>
+            <a:ext cx="10698480" cy="731520"/>
           </a:xfrm>
           <a:prstGeom prst="rect">
             <a:avLst/>
@@ -6591,7 +6631,7 @@
                 <a:ea typeface="Calibri" pitchFamily="34" charset="-122"/>
                 <a:cs typeface="Calibri" pitchFamily="34" charset="-120"/>
               </a:rPr>
-              <a:t>El edificio, la operación de renta corta y la facturación ya existen. Falta un proceso que encuentre, filtre y cierre con el comprador correcto.</a:t>
+              <a:t>El edificio, la operación de renta corta y la facturación ya existen. Falta un canal digital que genere y filtre interesados reales, antes de que lleguen a los propietarios.</a:t>
             </a:r>
             <a:endParaRPr lang="en-US" sz="1500" dirty="0"/>
           </a:p>
@@ -6732,7 +6772,7 @@
               <a:buNone/>
             </a:pPr>
             <a:r>
-              <a:rPr lang="en-US" sz="3200" b="1" dirty="0">
+              <a:rPr lang="en-US" sz="3000" b="1" dirty="0">
                 <a:solidFill>
                   <a:srgbClr val="1C1F26"/>
                 </a:solidFill>
@@ -6742,7 +6782,7 @@
               </a:rPr>
               <a:t>Vender un edificio completo no es vender un apartamento.</a:t>
             </a:r>
-            <a:endParaRPr lang="en-US" sz="3200" dirty="0"/>
+            <a:endParaRPr lang="en-US" sz="3000" dirty="0"/>
           </a:p>
         </p:txBody>
       </p:sp>
@@ -6779,7 +6819,7 @@
                 <a:ea typeface="Calibri" pitchFamily="34" charset="-122"/>
                 <a:cs typeface="Calibri" pitchFamily="34" charset="-120"/>
               </a:rPr>
-              <a:t>VENTA CONVENCIONAL</a:t>
+              <a:t>MERCADEO CONVENCIONAL</a:t>
             </a:r>
             <a:endParaRPr lang="en-US" sz="1500" dirty="0"/>
           </a:p>
@@ -6818,7 +6858,7 @@
                 <a:ea typeface="Calibri" pitchFamily="34" charset="-122"/>
                 <a:cs typeface="Calibri" pitchFamily="34" charset="-120"/>
               </a:rPr>
-              <a:t>VENTA DE ACTIVO ÚNICO</a:t>
+              <a:t>DIFUSIÓN DE ACTIVO ÚNICO</a:t>
             </a:r>
             <a:endParaRPr lang="en-US" sz="1500" dirty="0"/>
           </a:p>
@@ -6857,7 +6897,7 @@
                 <a:ea typeface="Calibri" pitchFamily="34" charset="-122"/>
                 <a:cs typeface="Calibri" pitchFamily="34" charset="-120"/>
               </a:rPr>
-              <a:t>Se vende por apartamentos individuales</a:t>
+              <a:t>Cualquier persona puede interesarse</a:t>
             </a:r>
             <a:endParaRPr lang="en-US" sz="1400" dirty="0"/>
           </a:p>
@@ -6896,7 +6936,7 @@
                 <a:ea typeface="Calibri" pitchFamily="34" charset="-122"/>
                 <a:cs typeface="Calibri" pitchFamily="34" charset="-120"/>
               </a:rPr>
-              <a:t>Se vende el edificio completo, como sociedad o activo</a:t>
+              <a:t>Solo interesados con capacidad de compra total</a:t>
             </a:r>
             <a:endParaRPr lang="en-US" sz="1400" dirty="0"/>
           </a:p>
@@ -6935,7 +6975,7 @@
                 <a:ea typeface="Calibri" pitchFamily="34" charset="-122"/>
                 <a:cs typeface="Calibri" pitchFamily="34" charset="-120"/>
               </a:rPr>
-              <a:t>Cualquier comprador califica</a:t>
+              <a:t>Mercadeo abierto y masivo</a:t>
             </a:r>
             <a:endParaRPr lang="en-US" sz="1400" dirty="0"/>
           </a:p>
@@ -6974,7 +7014,7 @@
                 <a:ea typeface="Calibri" pitchFamily="34" charset="-122"/>
                 <a:cs typeface="Calibri" pitchFamily="34" charset="-120"/>
               </a:rPr>
-              <a:t>Solo compradores con capacidad de compra total</a:t>
+              <a:t>Difusión discreta, filtrada digitalmente</a:t>
             </a:r>
             <a:endParaRPr lang="en-US" sz="1400" dirty="0"/>
           </a:p>
@@ -7013,7 +7053,7 @@
                 <a:ea typeface="Calibri" pitchFamily="34" charset="-122"/>
                 <a:cs typeface="Calibri" pitchFamily="34" charset="-120"/>
               </a:rPr>
-              <a:t>Mercadeo abierto y masivo</a:t>
+              <a:t>El anuncio muestra todo de entrada</a:t>
             </a:r>
             <a:endParaRPr lang="en-US" sz="1400" dirty="0"/>
           </a:p>
@@ -7052,7 +7092,7 @@
                 <a:ea typeface="Calibri" pitchFamily="34" charset="-122"/>
                 <a:cs typeface="Calibri" pitchFamily="34" charset="-120"/>
               </a:rPr>
-              <a:t>Difusión discreta, filtrada y confidencial</a:t>
+              <a:t>El anuncio es un teaser, sin datos sensibles</a:t>
             </a:r>
             <a:endParaRPr lang="en-US" sz="1400" dirty="0"/>
           </a:p>
@@ -7091,7 +7131,7 @@
                 <a:ea typeface="Calibri" pitchFamily="34" charset="-122"/>
                 <a:cs typeface="Calibri" pitchFamily="34" charset="-120"/>
               </a:rPr>
-              <a:t>El comprador ve todo desde el primer anuncio</a:t>
+              <a:t>Se generan miles de curiosos</a:t>
             </a:r>
             <a:endParaRPr lang="en-US" sz="1400" dirty="0"/>
           </a:p>
@@ -7130,7 +7170,7 @@
                 <a:ea typeface="Calibri" pitchFamily="34" charset="-122"/>
                 <a:cs typeface="Calibri" pitchFamily="34" charset="-120"/>
               </a:rPr>
-              <a:t>La información sensible se entrega solo bajo NDA</a:t>
+              <a:t>Se filtran curiosos antes de generar el contacto</a:t>
             </a:r>
             <a:endParaRPr lang="en-US" sz="1400" dirty="0"/>
           </a:p>
@@ -7145,7 +7185,7 @@
         <p:spPr>
           <a:xfrm>
             <a:off x="640080" y="6291072"/>
-            <a:ext cx="10058400" cy="320040"/>
+            <a:ext cx="10607040" cy="320040"/>
           </a:xfrm>
           <a:prstGeom prst="rect">
             <a:avLst/>
@@ -7169,7 +7209,7 @@
                 <a:ea typeface="Calibri" pitchFamily="34" charset="-122"/>
                 <a:cs typeface="Calibri" pitchFamily="34" charset="-120"/>
               </a:rPr>
-              <a:t>Hosty56 no está constituido en propiedad horizontal: no puede fraccionarse ni venderse por unidades.</a:t>
+              <a:t>Hosty56 no está constituido en propiedad horizontal: no puede fraccionarse ni venderse por unidades, solo completo.</a:t>
             </a:r>
             <a:endParaRPr lang="en-US" sz="1050" dirty="0"/>
           </a:p>
@@ -7310,7 +7350,7 @@
               <a:buNone/>
             </a:pPr>
             <a:r>
-              <a:rPr lang="en-US" sz="3200" b="1" dirty="0">
+              <a:rPr lang="en-US" sz="3000" b="1" dirty="0">
                 <a:solidFill>
                   <a:srgbClr val="1C1F26"/>
                 </a:solidFill>
@@ -7320,7 +7360,7 @@
               </a:rPr>
               <a:t>Hosty56</a:t>
             </a:r>
-            <a:endParaRPr lang="en-US" sz="3200" dirty="0"/>
+            <a:endParaRPr lang="en-US" sz="3000" dirty="0"/>
           </a:p>
         </p:txBody>
       </p:sp>
@@ -7976,7 +8016,7 @@
         <p:spPr>
           <a:xfrm>
             <a:off x="640080" y="6291072"/>
-            <a:ext cx="10058400" cy="320040"/>
+            <a:ext cx="10607040" cy="320040"/>
           </a:xfrm>
           <a:prstGeom prst="rect">
             <a:avLst/>
@@ -8000,7 +8040,7 @@
                 <a:ea typeface="Calibri" pitchFamily="34" charset="-122"/>
                 <a:cs typeface="Calibri" pitchFamily="34" charset="-120"/>
               </a:rPr>
-              <a:t>Cifra bruta: antes de gastos operativos, servicio de hipoteca e impuestos.</a:t>
+              <a:t>Cifra bruta: antes de gastos operativos, servicio de hipoteca e impuestos. Base para la comunicación de la campaña.</a:t>
             </a:r>
             <a:endParaRPr lang="en-US" sz="1050" dirty="0"/>
           </a:p>
@@ -8110,7 +8150,7 @@
                 <a:ea typeface="Calibri" pitchFamily="34" charset="-122"/>
                 <a:cs typeface="Calibri" pitchFamily="34" charset="-120"/>
               </a:rPr>
-              <a:t>LA PROPUESTA</a:t>
+              <a:t>MI GESTIÓN</a:t>
             </a:r>
             <a:endParaRPr lang="en-US" sz="1300" dirty="0"/>
           </a:p>
@@ -8141,7 +8181,7 @@
               <a:buNone/>
             </a:pPr>
             <a:r>
-              <a:rPr lang="en-US" sz="3200" b="1" dirty="0">
+              <a:rPr lang="en-US" sz="3000" b="1" dirty="0">
                 <a:solidFill>
                   <a:srgbClr val="1C1F26"/>
                 </a:solidFill>
@@ -8149,9 +8189,9 @@
                 <a:ea typeface="Cambria" pitchFamily="34" charset="-122"/>
                 <a:cs typeface="Cambria" pitchFamily="34" charset="-120"/>
               </a:rPr>
-              <a:t>Un proceso discreto de cuatro etapas</a:t>
-            </a:r>
-            <a:endParaRPr lang="en-US" sz="3200" dirty="0"/>
+              <a:t>Genero y filtro interesados. Ustedes gestionan el resto.</a:t>
+            </a:r>
+            <a:endParaRPr lang="en-US" sz="3000" dirty="0"/>
           </a:p>
         </p:txBody>
       </p:sp>
@@ -8188,7 +8228,7 @@
                 <a:ea typeface="Calibri" pitchFamily="34" charset="-122"/>
                 <a:cs typeface="Calibri" pitchFamily="34" charset="-120"/>
               </a:rPr>
-              <a:t>Cada etapa filtra y avanza hacia el comprador correcto.</a:t>
+              <a:t>Este plan cubre únicamente la parte digital del proceso.</a:t>
             </a:r>
             <a:endParaRPr lang="en-US" sz="1600" dirty="0"/>
           </a:p>
@@ -8196,42 +8236,25 @@
       </p:sp>
       <p:sp>
         <p:nvSpPr>
-          <p:cNvPr id="5" name="Text 3"/>
-          <p:cNvSpPr/>
-          <p:nvPr/>
-        </p:nvSpPr>
-        <p:spPr>
-          <a:xfrm>
-            <a:off x="777240" y="2240280"/>
-            <a:ext cx="2377440" cy="457200"/>
-          </a:xfrm>
-          <a:prstGeom prst="rect">
-            <a:avLst/>
-          </a:prstGeom>
-          <a:noFill/>
-          <a:ln/>
-        </p:spPr>
-        <p:txBody>
-          <a:bodyPr wrap="square" lIns="0" tIns="0" rIns="0" bIns="0" rtlCol="0" anchor="ctr"/>
-          <a:lstStyle/>
-          <a:p>
-            <a:pPr indent="0" marL="0">
-              <a:buNone/>
-            </a:pPr>
-            <a:r>
-              <a:rPr lang="en-US" sz="2000" b="1" dirty="0">
-                <a:solidFill>
-                  <a:srgbClr val="B08D57"/>
-                </a:solidFill>
-                <a:latin typeface="Cambria" pitchFamily="34" charset="0"/>
-                <a:ea typeface="Cambria" pitchFamily="34" charset="-122"/>
-                <a:cs typeface="Cambria" pitchFamily="34" charset="-120"/>
-              </a:rPr>
-              <a:t>01</a:t>
-            </a:r>
-            <a:endParaRPr lang="en-US" sz="2000" dirty="0"/>
-          </a:p>
-        </p:txBody>
+          <p:cNvPr id="5" name="Shape 3"/>
+          <p:cNvSpPr/>
+          <p:nvPr/>
+        </p:nvSpPr>
+        <p:spPr>
+          <a:xfrm>
+            <a:off x="640080" y="2331720"/>
+            <a:ext cx="5120640" cy="3566160"/>
+          </a:xfrm>
+          <a:prstGeom prst="roundRect">
+            <a:avLst>
+              <a:gd name="adj" fmla="val 2051"/>
+            </a:avLst>
+          </a:prstGeom>
+          <a:solidFill>
+            <a:srgbClr val="F2F1EE"/>
+          </a:solidFill>
+          <a:ln/>
+        </p:spPr>
       </p:sp>
       <p:sp>
         <p:nvSpPr>
@@ -8241,11 +8264,13 @@
         </p:nvSpPr>
         <p:spPr>
           <a:xfrm>
-            <a:off x="1600200" y="2743200"/>
-            <a:ext cx="731520" cy="731520"/>
-          </a:xfrm>
-          <a:prstGeom prst="ellipse">
-            <a:avLst/>
+            <a:off x="6172200" y="2331720"/>
+            <a:ext cx="5120640" cy="3566160"/>
+          </a:xfrm>
+          <a:prstGeom prst="roundRect">
+            <a:avLst>
+              <a:gd name="adj" fmla="val 2051"/>
+            </a:avLst>
           </a:prstGeom>
           <a:solidFill>
             <a:srgbClr val="1C1F26"/>
@@ -8253,56 +8278,114 @@
           <a:ln/>
         </p:spPr>
       </p:sp>
-      <p:pic>
-        <p:nvPicPr>
-          <p:cNvPr id="7" name="Image 0" descr="/tmp/hosty56_build/icons/eye_gold.png">    </p:cNvPr>
-          <p:cNvPicPr>
-            <a:picLocks noChangeAspect="1"/>
-          </p:cNvPicPr>
-          <p:nvPr/>
-        </p:nvPicPr>
-        <p:blipFill>
-          <a:blip r:embed="rId1"/>
-          <a:stretch>
-            <a:fillRect/>
-          </a:stretch>
-        </p:blipFill>
-        <p:spPr>
-          <a:xfrm>
-            <a:off x="1753819" y="2896819"/>
-            <a:ext cx="424282" cy="424282"/>
-          </a:xfrm>
-          <a:prstGeom prst="rect">
-            <a:avLst/>
-          </a:prstGeom>
-        </p:spPr>
-      </p:pic>
-      <p:sp>
-        <p:nvSpPr>
-          <p:cNvPr id="8" name="Text 5"/>
-          <p:cNvSpPr/>
-          <p:nvPr/>
-        </p:nvSpPr>
-        <p:spPr>
-          <a:xfrm>
-            <a:off x="777240" y="3657600"/>
-            <a:ext cx="2377440" cy="640080"/>
-          </a:xfrm>
-          <a:prstGeom prst="rect">
-            <a:avLst/>
-          </a:prstGeom>
-          <a:noFill/>
-          <a:ln/>
-        </p:spPr>
-        <p:txBody>
-          <a:bodyPr wrap="square" lIns="0" tIns="0" rIns="0" bIns="0" rtlCol="0" anchor="ctr"/>
-          <a:lstStyle/>
-          <a:p>
-            <a:pPr algn="ctr" indent="0" marL="0">
-              <a:buNone/>
-            </a:pPr>
-            <a:r>
-              <a:rPr lang="en-US" sz="1500" b="1" dirty="0">
+      <p:sp>
+        <p:nvSpPr>
+          <p:cNvPr id="7" name="Text 5"/>
+          <p:cNvSpPr/>
+          <p:nvPr/>
+        </p:nvSpPr>
+        <p:spPr>
+          <a:xfrm>
+            <a:off x="960120" y="2560320"/>
+            <a:ext cx="4480560" cy="365760"/>
+          </a:xfrm>
+          <a:prstGeom prst="rect">
+            <a:avLst/>
+          </a:prstGeom>
+          <a:noFill/>
+          <a:ln/>
+        </p:spPr>
+        <p:txBody>
+          <a:bodyPr wrap="square" lIns="0" tIns="0" rIns="0" bIns="0" rtlCol="0" anchor="ctr"/>
+          <a:lstStyle/>
+          <a:p>
+            <a:pPr indent="0" marL="0">
+              <a:buNone/>
+            </a:pPr>
+            <a:r>
+              <a:rPr lang="en-US" sz="1400" b="1" spc="100" kern="0" dirty="0">
+                <a:solidFill>
+                  <a:srgbClr val="B08D57"/>
+                </a:solidFill>
+                <a:latin typeface="Calibri" pitchFamily="34" charset="0"/>
+                <a:ea typeface="Calibri" pitchFamily="34" charset="-122"/>
+                <a:cs typeface="Calibri" pitchFamily="34" charset="-120"/>
+              </a:rPr>
+              <a:t>MI GESTIÓN (META ADS)</a:t>
+            </a:r>
+            <a:endParaRPr lang="en-US" sz="1400" dirty="0"/>
+          </a:p>
+        </p:txBody>
+      </p:sp>
+      <p:sp>
+        <p:nvSpPr>
+          <p:cNvPr id="8" name="Text 6"/>
+          <p:cNvSpPr/>
+          <p:nvPr/>
+        </p:nvSpPr>
+        <p:spPr>
+          <a:xfrm>
+            <a:off x="6492240" y="2560320"/>
+            <a:ext cx="4480560" cy="365760"/>
+          </a:xfrm>
+          <a:prstGeom prst="rect">
+            <a:avLst/>
+          </a:prstGeom>
+          <a:noFill/>
+          <a:ln/>
+        </p:spPr>
+        <p:txBody>
+          <a:bodyPr wrap="square" lIns="0" tIns="0" rIns="0" bIns="0" rtlCol="0" anchor="ctr"/>
+          <a:lstStyle/>
+          <a:p>
+            <a:pPr indent="0" marL="0">
+              <a:buNone/>
+            </a:pPr>
+            <a:r>
+              <a:rPr lang="en-US" sz="1400" b="1" spc="100" kern="0" dirty="0">
+                <a:solidFill>
+                  <a:srgbClr val="B08D57"/>
+                </a:solidFill>
+                <a:latin typeface="Calibri" pitchFamily="34" charset="0"/>
+                <a:ea typeface="Calibri" pitchFamily="34" charset="-122"/>
+                <a:cs typeface="Calibri" pitchFamily="34" charset="-120"/>
+              </a:rPr>
+              <a:t>GESTIÓN DE LOS PROPIETARIOS</a:t>
+            </a:r>
+            <a:endParaRPr lang="en-US" sz="1400" dirty="0"/>
+          </a:p>
+        </p:txBody>
+      </p:sp>
+      <p:sp>
+        <p:nvSpPr>
+          <p:cNvPr id="9" name="Text 7"/>
+          <p:cNvSpPr/>
+          <p:nvPr/>
+        </p:nvSpPr>
+        <p:spPr>
+          <a:xfrm>
+            <a:off x="960120" y="3063240"/>
+            <a:ext cx="4480560" cy="2651760"/>
+          </a:xfrm>
+          <a:prstGeom prst="rect">
+            <a:avLst/>
+          </a:prstGeom>
+          <a:noFill/>
+          <a:ln/>
+        </p:spPr>
+        <p:txBody>
+          <a:bodyPr wrap="square" lIns="0" tIns="0" rIns="0" bIns="0" rtlCol="0" anchor="t"/>
+          <a:lstStyle/>
+          <a:p>
+            <a:pPr marL="342900" indent="-342900">
+              <a:spcAft>
+                <a:spcPts val="1000"/>
+              </a:spcAft>
+              <a:buSzPct val="100000"/>
+              <a:buChar char="•"/>
+            </a:pPr>
+            <a:r>
+              <a:rPr lang="en-US" sz="1350" dirty="0">
                 <a:solidFill>
                   <a:srgbClr val="1C1F26"/>
                 </a:solidFill>
@@ -8310,16 +8393,20 @@
                 <a:ea typeface="Calibri" pitchFamily="34" charset="-122"/>
                 <a:cs typeface="Calibri" pitchFamily="34" charset="-120"/>
               </a:rPr>
-              <a:t>Difusión</a:t>
-            </a:r>
-            <a:endParaRPr lang="en-US" sz="1500" dirty="0"/>
-          </a:p>
-          <a:p>
-            <a:pPr algn="ctr" indent="0" marL="0">
-              <a:buNone/>
-            </a:pPr>
-            <a:r>
-              <a:rPr lang="en-US" sz="1500" b="1" dirty="0">
+              <a:t>Difusión discreta del teaser</a:t>
+            </a:r>
+            <a:endParaRPr lang="en-US" sz="1350" dirty="0"/>
+          </a:p>
+          <a:p>
+            <a:pPr marL="342900" indent="-342900">
+              <a:spcAft>
+                <a:spcPts val="1000"/>
+              </a:spcAft>
+              <a:buSzPct val="100000"/>
+              <a:buChar char="•"/>
+            </a:pPr>
+            <a:r>
+              <a:rPr lang="en-US" sz="1350" dirty="0">
                 <a:solidFill>
                   <a:srgbClr val="1C1F26"/>
                 </a:solidFill>
@@ -8327,184 +8414,20 @@
                 <a:ea typeface="Calibri" pitchFamily="34" charset="-122"/>
                 <a:cs typeface="Calibri" pitchFamily="34" charset="-120"/>
               </a:rPr>
-              <a:t>discreta</a:t>
-            </a:r>
-            <a:endParaRPr lang="en-US" sz="1500" dirty="0"/>
-          </a:p>
-        </p:txBody>
-      </p:sp>
-      <p:sp>
-        <p:nvSpPr>
-          <p:cNvPr id="9" name="Text 6"/>
-          <p:cNvSpPr/>
-          <p:nvPr/>
-        </p:nvSpPr>
-        <p:spPr>
-          <a:xfrm>
-            <a:off x="777240" y="4251960"/>
-            <a:ext cx="2377440" cy="365760"/>
-          </a:xfrm>
-          <a:prstGeom prst="rect">
-            <a:avLst/>
-          </a:prstGeom>
-          <a:noFill/>
-          <a:ln/>
-        </p:spPr>
-        <p:txBody>
-          <a:bodyPr wrap="square" lIns="0" tIns="0" rIns="0" bIns="0" rtlCol="0" anchor="ctr"/>
-          <a:lstStyle/>
-          <a:p>
-            <a:pPr algn="ctr" indent="0" marL="0">
-              <a:buNone/>
-            </a:pPr>
-            <a:r>
-              <a:rPr lang="en-US" sz="1250" i="1" dirty="0">
-                <a:solidFill>
-                  <a:srgbClr val="6B6B66"/>
-                </a:solidFill>
-                <a:latin typeface="Calibri" pitchFamily="34" charset="0"/>
-                <a:ea typeface="Calibri" pitchFamily="34" charset="-122"/>
-                <a:cs typeface="Calibri" pitchFamily="34" charset="-120"/>
-              </a:rPr>
-              <a:t>Descubrir</a:t>
-            </a:r>
-            <a:endParaRPr lang="en-US" sz="1250" dirty="0"/>
-          </a:p>
-        </p:txBody>
-      </p:sp>
-      <p:pic>
-        <p:nvPicPr>
-          <p:cNvPr id="10" name="Image 1" descr="/tmp/hosty56_build/icons/arrowRight_charcoal.png">    </p:cNvPr>
-          <p:cNvPicPr>
-            <a:picLocks noChangeAspect="1"/>
-          </p:cNvPicPr>
-          <p:nvPr/>
-        </p:nvPicPr>
-        <p:blipFill>
-          <a:blip r:embed="rId2"/>
-          <a:stretch>
-            <a:fillRect/>
-          </a:stretch>
-        </p:blipFill>
-        <p:spPr>
-          <a:xfrm>
-            <a:off x="3209544" y="2926080"/>
-            <a:ext cx="320040" cy="320040"/>
-          </a:xfrm>
-          <a:prstGeom prst="rect">
-            <a:avLst/>
-          </a:prstGeom>
-        </p:spPr>
-      </p:pic>
-      <p:sp>
-        <p:nvSpPr>
-          <p:cNvPr id="11" name="Text 7"/>
-          <p:cNvSpPr/>
-          <p:nvPr/>
-        </p:nvSpPr>
-        <p:spPr>
-          <a:xfrm>
-            <a:off x="3611880" y="2240280"/>
-            <a:ext cx="2377440" cy="457200"/>
-          </a:xfrm>
-          <a:prstGeom prst="rect">
-            <a:avLst/>
-          </a:prstGeom>
-          <a:noFill/>
-          <a:ln/>
-        </p:spPr>
-        <p:txBody>
-          <a:bodyPr wrap="square" lIns="0" tIns="0" rIns="0" bIns="0" rtlCol="0" anchor="ctr"/>
-          <a:lstStyle/>
-          <a:p>
-            <a:pPr indent="0" marL="0">
-              <a:buNone/>
-            </a:pPr>
-            <a:r>
-              <a:rPr lang="en-US" sz="2000" b="1" dirty="0">
-                <a:solidFill>
-                  <a:srgbClr val="B08D57"/>
-                </a:solidFill>
-                <a:latin typeface="Cambria" pitchFamily="34" charset="0"/>
-                <a:ea typeface="Cambria" pitchFamily="34" charset="-122"/>
-                <a:cs typeface="Cambria" pitchFamily="34" charset="-120"/>
-              </a:rPr>
-              <a:t>02</a:t>
-            </a:r>
-            <a:endParaRPr lang="en-US" sz="2000" dirty="0"/>
-          </a:p>
-        </p:txBody>
-      </p:sp>
-      <p:sp>
-        <p:nvSpPr>
-          <p:cNvPr id="12" name="Shape 8"/>
-          <p:cNvSpPr/>
-          <p:nvPr/>
-        </p:nvSpPr>
-        <p:spPr>
-          <a:xfrm>
-            <a:off x="4434840" y="2743200"/>
-            <a:ext cx="731520" cy="731520"/>
-          </a:xfrm>
-          <a:prstGeom prst="ellipse">
-            <a:avLst/>
-          </a:prstGeom>
-          <a:solidFill>
-            <a:srgbClr val="1C1F26"/>
-          </a:solidFill>
-          <a:ln/>
-        </p:spPr>
-      </p:sp>
-      <p:pic>
-        <p:nvPicPr>
-          <p:cNvPr id="13" name="Image 2" descr="/tmp/hosty56_build/icons/fileSignature_gold.png">    </p:cNvPr>
-          <p:cNvPicPr>
-            <a:picLocks noChangeAspect="1"/>
-          </p:cNvPicPr>
-          <p:nvPr/>
-        </p:nvPicPr>
-        <p:blipFill>
-          <a:blip r:embed="rId3"/>
-          <a:stretch>
-            <a:fillRect/>
-          </a:stretch>
-        </p:blipFill>
-        <p:spPr>
-          <a:xfrm>
-            <a:off x="4588459" y="2896819"/>
-            <a:ext cx="424282" cy="424282"/>
-          </a:xfrm>
-          <a:prstGeom prst="rect">
-            <a:avLst/>
-          </a:prstGeom>
-        </p:spPr>
-      </p:pic>
-      <p:sp>
-        <p:nvSpPr>
-          <p:cNvPr id="14" name="Text 9"/>
-          <p:cNvSpPr/>
-          <p:nvPr/>
-        </p:nvSpPr>
-        <p:spPr>
-          <a:xfrm>
-            <a:off x="3611880" y="3657600"/>
-            <a:ext cx="2377440" cy="640080"/>
-          </a:xfrm>
-          <a:prstGeom prst="rect">
-            <a:avLst/>
-          </a:prstGeom>
-          <a:noFill/>
-          <a:ln/>
-        </p:spPr>
-        <p:txBody>
-          <a:bodyPr wrap="square" lIns="0" tIns="0" rIns="0" bIns="0" rtlCol="0" anchor="ctr"/>
-          <a:lstStyle/>
-          <a:p>
-            <a:pPr algn="ctr" indent="0" marL="0">
-              <a:buNone/>
-            </a:pPr>
-            <a:r>
-              <a:rPr lang="en-US" sz="1500" b="1" dirty="0">
+              <a:t>Landing y formulario de calificación</a:t>
+            </a:r>
+            <a:endParaRPr lang="en-US" sz="1350" dirty="0"/>
+          </a:p>
+          <a:p>
+            <a:pPr marL="342900" indent="-342900">
+              <a:spcAft>
+                <a:spcPts val="1000"/>
+              </a:spcAft>
+              <a:buSzPct val="100000"/>
+              <a:buChar char="•"/>
+            </a:pPr>
+            <a:r>
+              <a:rPr lang="en-US" sz="1350" dirty="0">
                 <a:solidFill>
                   <a:srgbClr val="1C1F26"/>
                 </a:solidFill>
@@ -8512,16 +8435,20 @@
                 <a:ea typeface="Calibri" pitchFamily="34" charset="-122"/>
                 <a:cs typeface="Calibri" pitchFamily="34" charset="-120"/>
               </a:rPr>
-              <a:t>Calificación</a:t>
-            </a:r>
-            <a:endParaRPr lang="en-US" sz="1500" dirty="0"/>
-          </a:p>
-          <a:p>
-            <a:pPr algn="ctr" indent="0" marL="0">
-              <a:buNone/>
-            </a:pPr>
-            <a:r>
-              <a:rPr lang="en-US" sz="1500" b="1" dirty="0">
+              <a:t>Filtro automático de curiosos</a:t>
+            </a:r>
+            <a:endParaRPr lang="en-US" sz="1350" dirty="0"/>
+          </a:p>
+          <a:p>
+            <a:pPr marL="342900" indent="-342900">
+              <a:spcAft>
+                <a:spcPts val="1000"/>
+              </a:spcAft>
+              <a:buSzPct val="100000"/>
+              <a:buChar char="•"/>
+            </a:pPr>
+            <a:r>
+              <a:rPr lang="en-US" sz="1350" dirty="0">
                 <a:solidFill>
                   <a:srgbClr val="1C1F26"/>
                 </a:solidFill>
@@ -8529,497 +8456,121 @@
                 <a:ea typeface="Calibri" pitchFamily="34" charset="-122"/>
                 <a:cs typeface="Calibri" pitchFamily="34" charset="-120"/>
               </a:rPr>
-              <a:t>con NDA</a:t>
-            </a:r>
-            <a:endParaRPr lang="en-US" sz="1500" dirty="0"/>
-          </a:p>
-        </p:txBody>
-      </p:sp>
-      <p:sp>
-        <p:nvSpPr>
-          <p:cNvPr id="15" name="Text 10"/>
-          <p:cNvSpPr/>
-          <p:nvPr/>
-        </p:nvSpPr>
-        <p:spPr>
-          <a:xfrm>
-            <a:off x="3611880" y="4251960"/>
-            <a:ext cx="2377440" cy="365760"/>
-          </a:xfrm>
-          <a:prstGeom prst="rect">
-            <a:avLst/>
-          </a:prstGeom>
-          <a:noFill/>
-          <a:ln/>
-        </p:spPr>
-        <p:txBody>
-          <a:bodyPr wrap="square" lIns="0" tIns="0" rIns="0" bIns="0" rtlCol="0" anchor="ctr"/>
-          <a:lstStyle/>
-          <a:p>
-            <a:pPr algn="ctr" indent="0" marL="0">
-              <a:buNone/>
-            </a:pPr>
-            <a:r>
-              <a:rPr lang="en-US" sz="1250" i="1" dirty="0">
-                <a:solidFill>
-                  <a:srgbClr val="6B6B66"/>
-                </a:solidFill>
-                <a:latin typeface="Calibri" pitchFamily="34" charset="0"/>
-                <a:ea typeface="Calibri" pitchFamily="34" charset="-122"/>
-                <a:cs typeface="Calibri" pitchFamily="34" charset="-120"/>
-              </a:rPr>
-              <a:t>Filtrar</a:t>
-            </a:r>
-            <a:endParaRPr lang="en-US" sz="1250" dirty="0"/>
-          </a:p>
-        </p:txBody>
-      </p:sp>
-      <p:pic>
-        <p:nvPicPr>
-          <p:cNvPr id="16" name="Image 3" descr="/tmp/hosty56_build/icons/arrowRight_charcoal.png">    </p:cNvPr>
-          <p:cNvPicPr>
-            <a:picLocks noChangeAspect="1"/>
-          </p:cNvPicPr>
-          <p:nvPr/>
-        </p:nvPicPr>
-        <p:blipFill>
-          <a:blip r:embed="rId4"/>
-          <a:stretch>
-            <a:fillRect/>
-          </a:stretch>
-        </p:blipFill>
-        <p:spPr>
-          <a:xfrm>
-            <a:off x="6044184" y="2926080"/>
-            <a:ext cx="320040" cy="320040"/>
-          </a:xfrm>
-          <a:prstGeom prst="rect">
-            <a:avLst/>
-          </a:prstGeom>
-        </p:spPr>
-      </p:pic>
-      <p:sp>
-        <p:nvSpPr>
-          <p:cNvPr id="17" name="Text 11"/>
-          <p:cNvSpPr/>
-          <p:nvPr/>
-        </p:nvSpPr>
-        <p:spPr>
-          <a:xfrm>
-            <a:off x="6446520" y="2240280"/>
-            <a:ext cx="2377440" cy="457200"/>
-          </a:xfrm>
-          <a:prstGeom prst="rect">
-            <a:avLst/>
-          </a:prstGeom>
-          <a:noFill/>
-          <a:ln/>
-        </p:spPr>
-        <p:txBody>
-          <a:bodyPr wrap="square" lIns="0" tIns="0" rIns="0" bIns="0" rtlCol="0" anchor="ctr"/>
-          <a:lstStyle/>
-          <a:p>
-            <a:pPr indent="0" marL="0">
-              <a:buNone/>
-            </a:pPr>
-            <a:r>
-              <a:rPr lang="en-US" sz="2000" b="1" dirty="0">
-                <a:solidFill>
-                  <a:srgbClr val="B08D57"/>
-                </a:solidFill>
-                <a:latin typeface="Cambria" pitchFamily="34" charset="0"/>
-                <a:ea typeface="Cambria" pitchFamily="34" charset="-122"/>
-                <a:cs typeface="Cambria" pitchFamily="34" charset="-120"/>
-              </a:rPr>
-              <a:t>03</a:t>
-            </a:r>
-            <a:endParaRPr lang="en-US" sz="2000" dirty="0"/>
-          </a:p>
-        </p:txBody>
-      </p:sp>
-      <p:sp>
-        <p:nvSpPr>
-          <p:cNvPr id="18" name="Shape 12"/>
-          <p:cNvSpPr/>
-          <p:nvPr/>
-        </p:nvSpPr>
-        <p:spPr>
-          <a:xfrm>
-            <a:off x="7269480" y="2743200"/>
-            <a:ext cx="731520" cy="731520"/>
-          </a:xfrm>
-          <a:prstGeom prst="ellipse">
-            <a:avLst/>
-          </a:prstGeom>
-          <a:solidFill>
-            <a:srgbClr val="1C1F26"/>
-          </a:solidFill>
-          <a:ln/>
-        </p:spPr>
-      </p:sp>
-      <p:pic>
-        <p:nvPicPr>
-          <p:cNvPr id="19" name="Image 4" descr="/tmp/hosty56_build/icons/phone_gold.png">    </p:cNvPr>
-          <p:cNvPicPr>
-            <a:picLocks noChangeAspect="1"/>
-          </p:cNvPicPr>
-          <p:nvPr/>
-        </p:nvPicPr>
-        <p:blipFill>
-          <a:blip r:embed="rId5"/>
-          <a:stretch>
-            <a:fillRect/>
-          </a:stretch>
-        </p:blipFill>
-        <p:spPr>
-          <a:xfrm>
-            <a:off x="7423099" y="2896819"/>
-            <a:ext cx="424282" cy="424282"/>
-          </a:xfrm>
-          <a:prstGeom prst="rect">
-            <a:avLst/>
-          </a:prstGeom>
-        </p:spPr>
-      </p:pic>
-      <p:sp>
-        <p:nvSpPr>
-          <p:cNvPr id="20" name="Text 13"/>
-          <p:cNvSpPr/>
-          <p:nvPr/>
-        </p:nvSpPr>
-        <p:spPr>
-          <a:xfrm>
-            <a:off x="6446520" y="3657600"/>
-            <a:ext cx="2377440" cy="640080"/>
-          </a:xfrm>
-          <a:prstGeom prst="rect">
-            <a:avLst/>
-          </a:prstGeom>
-          <a:noFill/>
-          <a:ln/>
-        </p:spPr>
-        <p:txBody>
-          <a:bodyPr wrap="square" lIns="0" tIns="0" rIns="0" bIns="0" rtlCol="0" anchor="ctr"/>
-          <a:lstStyle/>
-          <a:p>
-            <a:pPr algn="ctr" indent="0" marL="0">
-              <a:buNone/>
-            </a:pPr>
-            <a:r>
-              <a:rPr lang="en-US" sz="1500" b="1" dirty="0">
-                <a:solidFill>
-                  <a:srgbClr val="1C1F26"/>
-                </a:solidFill>
-                <a:latin typeface="Calibri" pitchFamily="34" charset="0"/>
-                <a:ea typeface="Calibri" pitchFamily="34" charset="-122"/>
-                <a:cs typeface="Calibri" pitchFamily="34" charset="-120"/>
-              </a:rPr>
-              <a:t>Llamada de</a:t>
-            </a:r>
-            <a:endParaRPr lang="en-US" sz="1500" dirty="0"/>
-          </a:p>
-          <a:p>
-            <a:pPr algn="ctr" indent="0" marL="0">
-              <a:buNone/>
-            </a:pPr>
-            <a:r>
-              <a:rPr lang="en-US" sz="1500" b="1" dirty="0">
-                <a:solidFill>
-                  <a:srgbClr val="1C1F26"/>
-                </a:solidFill>
-                <a:latin typeface="Calibri" pitchFamily="34" charset="0"/>
-                <a:ea typeface="Calibri" pitchFamily="34" charset="-122"/>
-                <a:cs typeface="Calibri" pitchFamily="34" charset="-120"/>
-              </a:rPr>
-              <a:t>interés</a:t>
-            </a:r>
-            <a:endParaRPr lang="en-US" sz="1500" dirty="0"/>
-          </a:p>
-        </p:txBody>
-      </p:sp>
-      <p:sp>
-        <p:nvSpPr>
-          <p:cNvPr id="21" name="Text 14"/>
-          <p:cNvSpPr/>
-          <p:nvPr/>
-        </p:nvSpPr>
-        <p:spPr>
-          <a:xfrm>
-            <a:off x="6446520" y="4251960"/>
-            <a:ext cx="2377440" cy="365760"/>
-          </a:xfrm>
-          <a:prstGeom prst="rect">
-            <a:avLst/>
-          </a:prstGeom>
-          <a:noFill/>
-          <a:ln/>
-        </p:spPr>
-        <p:txBody>
-          <a:bodyPr wrap="square" lIns="0" tIns="0" rIns="0" bIns="0" rtlCol="0" anchor="ctr"/>
-          <a:lstStyle/>
-          <a:p>
-            <a:pPr algn="ctr" indent="0" marL="0">
-              <a:buNone/>
-            </a:pPr>
-            <a:r>
-              <a:rPr lang="en-US" sz="1250" i="1" dirty="0">
-                <a:solidFill>
-                  <a:srgbClr val="6B6B66"/>
-                </a:solidFill>
-                <a:latin typeface="Calibri" pitchFamily="34" charset="0"/>
-                <a:ea typeface="Calibri" pitchFamily="34" charset="-122"/>
-                <a:cs typeface="Calibri" pitchFamily="34" charset="-120"/>
-              </a:rPr>
-              <a:t>Confirmar</a:t>
-            </a:r>
-            <a:endParaRPr lang="en-US" sz="1250" dirty="0"/>
-          </a:p>
-        </p:txBody>
-      </p:sp>
-      <p:pic>
-        <p:nvPicPr>
-          <p:cNvPr id="22" name="Image 5" descr="/tmp/hosty56_build/icons/arrowRight_charcoal.png">    </p:cNvPr>
-          <p:cNvPicPr>
-            <a:picLocks noChangeAspect="1"/>
-          </p:cNvPicPr>
-          <p:nvPr/>
-        </p:nvPicPr>
-        <p:blipFill>
-          <a:blip r:embed="rId6"/>
-          <a:stretch>
-            <a:fillRect/>
-          </a:stretch>
-        </p:blipFill>
-        <p:spPr>
-          <a:xfrm>
-            <a:off x="8878824" y="2926080"/>
-            <a:ext cx="320040" cy="320040"/>
-          </a:xfrm>
-          <a:prstGeom prst="rect">
-            <a:avLst/>
-          </a:prstGeom>
-        </p:spPr>
-      </p:pic>
-      <p:sp>
-        <p:nvSpPr>
-          <p:cNvPr id="23" name="Text 15"/>
-          <p:cNvSpPr/>
-          <p:nvPr/>
-        </p:nvSpPr>
-        <p:spPr>
-          <a:xfrm>
-            <a:off x="9281160" y="2240280"/>
-            <a:ext cx="2377440" cy="457200"/>
-          </a:xfrm>
-          <a:prstGeom prst="rect">
-            <a:avLst/>
-          </a:prstGeom>
-          <a:noFill/>
-          <a:ln/>
-        </p:spPr>
-        <p:txBody>
-          <a:bodyPr wrap="square" lIns="0" tIns="0" rIns="0" bIns="0" rtlCol="0" anchor="ctr"/>
-          <a:lstStyle/>
-          <a:p>
-            <a:pPr indent="0" marL="0">
-              <a:buNone/>
-            </a:pPr>
-            <a:r>
-              <a:rPr lang="en-US" sz="2000" b="1" dirty="0">
-                <a:solidFill>
-                  <a:srgbClr val="B08D57"/>
-                </a:solidFill>
-                <a:latin typeface="Cambria" pitchFamily="34" charset="0"/>
-                <a:ea typeface="Cambria" pitchFamily="34" charset="-122"/>
-                <a:cs typeface="Cambria" pitchFamily="34" charset="-120"/>
-              </a:rPr>
-              <a:t>04</a:t>
-            </a:r>
-            <a:endParaRPr lang="en-US" sz="2000" dirty="0"/>
-          </a:p>
-        </p:txBody>
-      </p:sp>
-      <p:sp>
-        <p:nvSpPr>
-          <p:cNvPr id="24" name="Shape 16"/>
-          <p:cNvSpPr/>
-          <p:nvPr/>
-        </p:nvSpPr>
-        <p:spPr>
-          <a:xfrm>
-            <a:off x="10104120" y="2743200"/>
-            <a:ext cx="731520" cy="731520"/>
-          </a:xfrm>
-          <a:prstGeom prst="ellipse">
-            <a:avLst/>
-          </a:prstGeom>
-          <a:solidFill>
-            <a:srgbClr val="1C1F26"/>
-          </a:solidFill>
-          <a:ln/>
-        </p:spPr>
-      </p:sp>
-      <p:pic>
-        <p:nvPicPr>
-          <p:cNvPr id="25" name="Image 6" descr="/tmp/hosty56_build/icons/handshake_gold.png">    </p:cNvPr>
-          <p:cNvPicPr>
-            <a:picLocks noChangeAspect="1"/>
-          </p:cNvPicPr>
-          <p:nvPr/>
-        </p:nvPicPr>
-        <p:blipFill>
-          <a:blip r:embed="rId7"/>
-          <a:stretch>
-            <a:fillRect/>
-          </a:stretch>
-        </p:blipFill>
-        <p:spPr>
-          <a:xfrm>
-            <a:off x="10257739" y="2896819"/>
-            <a:ext cx="424282" cy="424282"/>
-          </a:xfrm>
-          <a:prstGeom prst="rect">
-            <a:avLst/>
-          </a:prstGeom>
-        </p:spPr>
-      </p:pic>
-      <p:sp>
-        <p:nvSpPr>
-          <p:cNvPr id="26" name="Text 17"/>
-          <p:cNvSpPr/>
-          <p:nvPr/>
-        </p:nvSpPr>
-        <p:spPr>
-          <a:xfrm>
-            <a:off x="9281160" y="3657600"/>
-            <a:ext cx="2377440" cy="640080"/>
-          </a:xfrm>
-          <a:prstGeom prst="rect">
-            <a:avLst/>
-          </a:prstGeom>
-          <a:noFill/>
-          <a:ln/>
-        </p:spPr>
-        <p:txBody>
-          <a:bodyPr wrap="square" lIns="0" tIns="0" rIns="0" bIns="0" rtlCol="0" anchor="ctr"/>
-          <a:lstStyle/>
-          <a:p>
-            <a:pPr algn="ctr" indent="0" marL="0">
-              <a:buNone/>
-            </a:pPr>
-            <a:r>
-              <a:rPr lang="en-US" sz="1500" b="1" dirty="0">
-                <a:solidFill>
-                  <a:srgbClr val="1C1F26"/>
-                </a:solidFill>
-                <a:latin typeface="Calibri" pitchFamily="34" charset="0"/>
-                <a:ea typeface="Calibri" pitchFamily="34" charset="-122"/>
-                <a:cs typeface="Calibri" pitchFamily="34" charset="-120"/>
-              </a:rPr>
-              <a:t>Visita y</a:t>
-            </a:r>
-            <a:endParaRPr lang="en-US" sz="1500" dirty="0"/>
-          </a:p>
-          <a:p>
-            <a:pPr algn="ctr" indent="0" marL="0">
-              <a:buNone/>
-            </a:pPr>
-            <a:r>
-              <a:rPr lang="en-US" sz="1500" b="1" dirty="0">
-                <a:solidFill>
-                  <a:srgbClr val="1C1F26"/>
-                </a:solidFill>
-                <a:latin typeface="Calibri" pitchFamily="34" charset="0"/>
-                <a:ea typeface="Calibri" pitchFamily="34" charset="-122"/>
-                <a:cs typeface="Calibri" pitchFamily="34" charset="-120"/>
-              </a:rPr>
-              <a:t>negociación</a:t>
-            </a:r>
-            <a:endParaRPr lang="en-US" sz="1500" dirty="0"/>
-          </a:p>
-        </p:txBody>
-      </p:sp>
-      <p:sp>
-        <p:nvSpPr>
-          <p:cNvPr id="27" name="Text 18"/>
-          <p:cNvSpPr/>
-          <p:nvPr/>
-        </p:nvSpPr>
-        <p:spPr>
-          <a:xfrm>
-            <a:off x="9281160" y="4251960"/>
-            <a:ext cx="2377440" cy="365760"/>
-          </a:xfrm>
-          <a:prstGeom prst="rect">
-            <a:avLst/>
-          </a:prstGeom>
-          <a:noFill/>
-          <a:ln/>
-        </p:spPr>
-        <p:txBody>
-          <a:bodyPr wrap="square" lIns="0" tIns="0" rIns="0" bIns="0" rtlCol="0" anchor="ctr"/>
-          <a:lstStyle/>
-          <a:p>
-            <a:pPr algn="ctr" indent="0" marL="0">
-              <a:buNone/>
-            </a:pPr>
-            <a:r>
-              <a:rPr lang="en-US" sz="1250" i="1" dirty="0">
-                <a:solidFill>
-                  <a:srgbClr val="6B6B66"/>
-                </a:solidFill>
-                <a:latin typeface="Calibri" pitchFamily="34" charset="0"/>
-                <a:ea typeface="Calibri" pitchFamily="34" charset="-122"/>
-                <a:cs typeface="Calibri" pitchFamily="34" charset="-120"/>
-              </a:rPr>
-              <a:t>Cerrar</a:t>
-            </a:r>
-            <a:endParaRPr lang="en-US" sz="1250" dirty="0"/>
-          </a:p>
-        </p:txBody>
-      </p:sp>
-      <p:sp>
-        <p:nvSpPr>
-          <p:cNvPr id="28" name="Text 19"/>
-          <p:cNvSpPr/>
-          <p:nvPr/>
-        </p:nvSpPr>
-        <p:spPr>
-          <a:xfrm>
-            <a:off x="640080" y="5486400"/>
-            <a:ext cx="10515600" cy="548640"/>
-          </a:xfrm>
-          <a:prstGeom prst="rect">
-            <a:avLst/>
-          </a:prstGeom>
-          <a:noFill/>
-          <a:ln/>
-        </p:spPr>
-        <p:txBody>
-          <a:bodyPr wrap="square" lIns="0" tIns="0" rIns="0" bIns="0" rtlCol="0" anchor="ctr"/>
-          <a:lstStyle/>
-          <a:p>
-            <a:pPr indent="0" marL="0">
-              <a:buNone/>
-            </a:pPr>
-            <a:r>
-              <a:rPr lang="en-US" sz="1450" i="1" dirty="0">
-                <a:solidFill>
-                  <a:srgbClr val="1C1F26"/>
-                </a:solidFill>
-                <a:latin typeface="Calibri" pitchFamily="34" charset="0"/>
-                <a:ea typeface="Calibri" pitchFamily="34" charset="-122"/>
-                <a:cs typeface="Calibri" pitchFamily="34" charset="-120"/>
-              </a:rPr>
-              <a:t>El resultado no es una tanda de anuncios: es un comprador único, calificado, que llega hasta la mesa de negociación.</a:t>
-            </a:r>
-            <a:endParaRPr lang="en-US" sz="1450" dirty="0"/>
-          </a:p>
-        </p:txBody>
-      </p:sp>
-      <p:sp>
-        <p:nvSpPr>
-          <p:cNvPr id="29" name="Text 20"/>
+              <a:t>Entrega de interesados calificados</a:t>
+            </a:r>
+            <a:endParaRPr lang="en-US" sz="1350" dirty="0"/>
+          </a:p>
+        </p:txBody>
+      </p:sp>
+      <p:sp>
+        <p:nvSpPr>
+          <p:cNvPr id="10" name="Text 8"/>
+          <p:cNvSpPr/>
+          <p:nvPr/>
+        </p:nvSpPr>
+        <p:spPr>
+          <a:xfrm>
+            <a:off x="6492240" y="3063240"/>
+            <a:ext cx="4480560" cy="2651760"/>
+          </a:xfrm>
+          <a:prstGeom prst="rect">
+            <a:avLst/>
+          </a:prstGeom>
+          <a:noFill/>
+          <a:ln/>
+        </p:spPr>
+        <p:txBody>
+          <a:bodyPr wrap="square" lIns="0" tIns="0" rIns="0" bIns="0" rtlCol="0" anchor="t"/>
+          <a:lstStyle/>
+          <a:p>
+            <a:pPr marL="342900" indent="-342900">
+              <a:spcAft>
+                <a:spcPts val="1000"/>
+              </a:spcAft>
+              <a:buSzPct val="100000"/>
+              <a:buChar char="•"/>
+            </a:pPr>
+            <a:r>
+              <a:rPr lang="en-US" sz="1350" dirty="0">
+                <a:solidFill>
+                  <a:srgbClr val="FFFFFF"/>
+                </a:solidFill>
+                <a:latin typeface="Calibri" pitchFamily="34" charset="0"/>
+                <a:ea typeface="Calibri" pitchFamily="34" charset="-122"/>
+                <a:cs typeface="Calibri" pitchFamily="34" charset="-120"/>
+              </a:rPr>
+              <a:t>NDA y entrega del dossier confidencial</a:t>
+            </a:r>
+            <a:endParaRPr lang="en-US" sz="1350" dirty="0"/>
+          </a:p>
+          <a:p>
+            <a:pPr marL="342900" indent="-342900">
+              <a:spcAft>
+                <a:spcPts val="1000"/>
+              </a:spcAft>
+              <a:buSzPct val="100000"/>
+              <a:buChar char="•"/>
+            </a:pPr>
+            <a:r>
+              <a:rPr lang="en-US" sz="1350" dirty="0">
+                <a:solidFill>
+                  <a:srgbClr val="FFFFFF"/>
+                </a:solidFill>
+                <a:latin typeface="Calibri" pitchFamily="34" charset="0"/>
+                <a:ea typeface="Calibri" pitchFamily="34" charset="-122"/>
+                <a:cs typeface="Calibri" pitchFamily="34" charset="-120"/>
+              </a:rPr>
+              <a:t>Llamadas de verificación y visitas</a:t>
+            </a:r>
+            <a:endParaRPr lang="en-US" sz="1350" dirty="0"/>
+          </a:p>
+          <a:p>
+            <a:pPr marL="342900" indent="-342900">
+              <a:spcAft>
+                <a:spcPts val="1000"/>
+              </a:spcAft>
+              <a:buSzPct val="100000"/>
+              <a:buChar char="•"/>
+            </a:pPr>
+            <a:r>
+              <a:rPr lang="en-US" sz="1350" dirty="0">
+                <a:solidFill>
+                  <a:srgbClr val="FFFFFF"/>
+                </a:solidFill>
+                <a:latin typeface="Calibri" pitchFamily="34" charset="0"/>
+                <a:ea typeface="Calibri" pitchFamily="34" charset="-122"/>
+                <a:cs typeface="Calibri" pitchFamily="34" charset="-120"/>
+              </a:rPr>
+              <a:t>Negociación y estructura legal</a:t>
+            </a:r>
+            <a:endParaRPr lang="en-US" sz="1350" dirty="0"/>
+          </a:p>
+          <a:p>
+            <a:pPr marL="342900" indent="-342900">
+              <a:spcAft>
+                <a:spcPts val="1000"/>
+              </a:spcAft>
+              <a:buSzPct val="100000"/>
+              <a:buChar char="•"/>
+            </a:pPr>
+            <a:r>
+              <a:rPr lang="en-US" sz="1350" dirty="0">
+                <a:solidFill>
+                  <a:srgbClr val="FFFFFF"/>
+                </a:solidFill>
+                <a:latin typeface="Calibri" pitchFamily="34" charset="0"/>
+                <a:ea typeface="Calibri" pitchFamily="34" charset="-122"/>
+                <a:cs typeface="Calibri" pitchFamily="34" charset="-120"/>
+              </a:rPr>
+              <a:t>Cierre de la venta</a:t>
+            </a:r>
+            <a:endParaRPr lang="en-US" sz="1350" dirty="0"/>
+          </a:p>
+        </p:txBody>
+      </p:sp>
+      <p:sp>
+        <p:nvSpPr>
+          <p:cNvPr id="11" name="Text 9"/>
           <p:cNvSpPr/>
           <p:nvPr/>
         </p:nvSpPr>
@@ -9097,7 +8648,7 @@
         <p:spPr>
           <a:xfrm>
             <a:off x="640080" y="457200"/>
-            <a:ext cx="5486400" cy="320040"/>
+            <a:ext cx="10881360" cy="320040"/>
           </a:xfrm>
           <a:prstGeom prst="rect">
             <a:avLst/>
@@ -9121,7 +8672,7 @@
                 <a:ea typeface="Calibri" pitchFamily="34" charset="-122"/>
                 <a:cs typeface="Calibri" pitchFamily="34" charset="-120"/>
               </a:rPr>
-              <a:t>ETAPA 01</a:t>
+              <a:t>LA ESTRATEGIA DIGITAL</a:t>
             </a:r>
             <a:endParaRPr lang="en-US" sz="1300" dirty="0"/>
           </a:p>
@@ -9136,23 +8687,23 @@
         <p:spPr>
           <a:xfrm>
             <a:off x="640080" y="777240"/>
-            <a:ext cx="7315200" cy="731520"/>
-          </a:xfrm>
-          <a:prstGeom prst="rect">
-            <a:avLst/>
-          </a:prstGeom>
-          <a:noFill/>
-          <a:ln/>
-        </p:spPr>
-        <p:txBody>
-          <a:bodyPr wrap="square" lIns="0" tIns="0" rIns="0" bIns="0" rtlCol="0" anchor="ctr"/>
-          <a:lstStyle/>
-          <a:p>
-            <a:pPr indent="0" marL="0">
-              <a:buNone/>
-            </a:pPr>
-            <a:r>
-              <a:rPr lang="en-US" sz="3200" b="1" dirty="0">
+            <a:ext cx="10881360" cy="822960"/>
+          </a:xfrm>
+          <a:prstGeom prst="rect">
+            <a:avLst/>
+          </a:prstGeom>
+          <a:noFill/>
+          <a:ln/>
+        </p:spPr>
+        <p:txBody>
+          <a:bodyPr wrap="square" lIns="0" tIns="0" rIns="0" bIns="0" rtlCol="0" anchor="ctr"/>
+          <a:lstStyle/>
+          <a:p>
+            <a:pPr indent="0" marL="0">
+              <a:buNone/>
+            </a:pPr>
+            <a:r>
+              <a:rPr lang="en-US" sz="3000" b="1" dirty="0">
                 <a:solidFill>
                   <a:srgbClr val="1C1F26"/>
                 </a:solidFill>
@@ -9160,9 +8711,9 @@
                 <a:ea typeface="Cambria" pitchFamily="34" charset="-122"/>
                 <a:cs typeface="Cambria" pitchFamily="34" charset="-120"/>
               </a:rPr>
-              <a:t>Difusión discreta</a:t>
-            </a:r>
-            <a:endParaRPr lang="en-US" sz="3200" dirty="0"/>
+              <a:t>Tres etapas para llegar al interesado correcto</a:t>
+            </a:r>
+            <a:endParaRPr lang="en-US" sz="3000" dirty="0"/>
           </a:p>
         </p:txBody>
       </p:sp>
@@ -9174,24 +8725,24 @@
         </p:nvSpPr>
         <p:spPr>
           <a:xfrm>
-            <a:off x="640080" y="1508760"/>
-            <a:ext cx="9875520" cy="457200"/>
-          </a:xfrm>
-          <a:prstGeom prst="rect">
-            <a:avLst/>
-          </a:prstGeom>
-          <a:noFill/>
-          <a:ln/>
-        </p:spPr>
-        <p:txBody>
-          <a:bodyPr wrap="square" lIns="0" tIns="0" rIns="0" bIns="0" rtlCol="0" anchor="ctr"/>
-          <a:lstStyle/>
-          <a:p>
-            <a:pPr indent="0" marL="0">
-              <a:buNone/>
-            </a:pPr>
-            <a:r>
-              <a:rPr lang="en-US" sz="1500" i="1" dirty="0">
+            <a:off x="640080" y="1463040"/>
+            <a:ext cx="10881360" cy="457200"/>
+          </a:xfrm>
+          <a:prstGeom prst="rect">
+            <a:avLst/>
+          </a:prstGeom>
+          <a:noFill/>
+          <a:ln/>
+        </p:spPr>
+        <p:txBody>
+          <a:bodyPr wrap="square" lIns="0" tIns="0" rIns="0" bIns="0" rtlCol="0" anchor="ctr"/>
+          <a:lstStyle/>
+          <a:p>
+            <a:pPr indent="0" marL="0">
+              <a:buNone/>
+            </a:pPr>
+            <a:r>
+              <a:rPr lang="en-US" sz="1600" i="1" dirty="0">
                 <a:solidFill>
                   <a:srgbClr val="6B6B66"/>
                 </a:solidFill>
@@ -9199,22 +8750,61 @@
                 <a:ea typeface="Calibri" pitchFamily="34" charset="-122"/>
                 <a:cs typeface="Calibri" pitchFamily="34" charset="-120"/>
               </a:rPr>
-              <a:t>Objetivo: generar interés calificado, sin exponer datos sensibles.</a:t>
-            </a:r>
-            <a:endParaRPr lang="en-US" sz="1500" dirty="0"/>
-          </a:p>
-        </p:txBody>
-      </p:sp>
-      <p:sp>
-        <p:nvSpPr>
-          <p:cNvPr id="5" name="Shape 3"/>
-          <p:cNvSpPr/>
-          <p:nvPr/>
-        </p:nvSpPr>
-        <p:spPr>
-          <a:xfrm>
-            <a:off x="10332720" y="548640"/>
-            <a:ext cx="914400" cy="914400"/>
+              <a:t>Cada etapa filtra: el objetivo no es alcance, es precisión.</a:t>
+            </a:r>
+            <a:endParaRPr lang="en-US" sz="1600" dirty="0"/>
+          </a:p>
+        </p:txBody>
+      </p:sp>
+      <p:sp>
+        <p:nvSpPr>
+          <p:cNvPr id="5" name="Text 3"/>
+          <p:cNvSpPr/>
+          <p:nvPr/>
+        </p:nvSpPr>
+        <p:spPr>
+          <a:xfrm>
+            <a:off x="1463040" y="2240280"/>
+            <a:ext cx="2651760" cy="457200"/>
+          </a:xfrm>
+          <a:prstGeom prst="rect">
+            <a:avLst/>
+          </a:prstGeom>
+          <a:noFill/>
+          <a:ln/>
+        </p:spPr>
+        <p:txBody>
+          <a:bodyPr wrap="square" lIns="0" tIns="0" rIns="0" bIns="0" rtlCol="0" anchor="ctr"/>
+          <a:lstStyle/>
+          <a:p>
+            <a:pPr indent="0" marL="0">
+              <a:buNone/>
+            </a:pPr>
+            <a:r>
+              <a:rPr lang="en-US" sz="2000" b="1" dirty="0">
+                <a:solidFill>
+                  <a:srgbClr val="B08D57"/>
+                </a:solidFill>
+                <a:latin typeface="Cambria" pitchFamily="34" charset="0"/>
+                <a:ea typeface="Cambria" pitchFamily="34" charset="-122"/>
+                <a:cs typeface="Cambria" pitchFamily="34" charset="-120"/>
+              </a:rPr>
+              <a:t>01</a:t>
+            </a:r>
+            <a:endParaRPr lang="en-US" sz="2000" dirty="0"/>
+          </a:p>
+        </p:txBody>
+      </p:sp>
+      <p:sp>
+        <p:nvSpPr>
+          <p:cNvPr id="6" name="Shape 4"/>
+          <p:cNvSpPr/>
+          <p:nvPr/>
+        </p:nvSpPr>
+        <p:spPr>
+          <a:xfrm>
+            <a:off x="2423160" y="2743200"/>
+            <a:ext cx="731520" cy="731520"/>
           </a:xfrm>
           <a:prstGeom prst="ellipse">
             <a:avLst/>
@@ -9227,7 +8817,7 @@
       </p:sp>
       <p:pic>
         <p:nvPicPr>
-          <p:cNvPr id="6" name="Image 0" descr="/tmp/hosty56_build/icons/eye_gold.png">    </p:cNvPr>
+          <p:cNvPr id="7" name="Image 0" descr="/tmp/hosty56_build/icons/eye_gold.png">    </p:cNvPr>
           <p:cNvPicPr>
             <a:picLocks noChangeAspect="1"/>
           </p:cNvPicPr>
@@ -9241,8 +8831,8 @@
         </p:blipFill>
         <p:spPr>
           <a:xfrm>
-            <a:off x="10538460" y="754380"/>
-            <a:ext cx="502920" cy="502920"/>
+            <a:off x="2576779" y="2896819"/>
+            <a:ext cx="424282" cy="424282"/>
           </a:xfrm>
           <a:prstGeom prst="rect">
             <a:avLst/>
@@ -9251,27 +8841,102 @@
       </p:pic>
       <p:sp>
         <p:nvSpPr>
-          <p:cNvPr id="7" name="Shape 4"/>
-          <p:cNvSpPr/>
-          <p:nvPr/>
-        </p:nvSpPr>
-        <p:spPr>
-          <a:xfrm>
-            <a:off x="640080" y="2331720"/>
-            <a:ext cx="502920" cy="502920"/>
-          </a:xfrm>
-          <a:prstGeom prst="ellipse">
-            <a:avLst/>
-          </a:prstGeom>
-          <a:solidFill>
-            <a:srgbClr val="F2F1EE"/>
-          </a:solidFill>
-          <a:ln/>
-        </p:spPr>
+          <p:cNvPr id="8" name="Text 5"/>
+          <p:cNvSpPr/>
+          <p:nvPr/>
+        </p:nvSpPr>
+        <p:spPr>
+          <a:xfrm>
+            <a:off x="1463040" y="3657600"/>
+            <a:ext cx="2651760" cy="640080"/>
+          </a:xfrm>
+          <a:prstGeom prst="rect">
+            <a:avLst/>
+          </a:prstGeom>
+          <a:noFill/>
+          <a:ln/>
+        </p:spPr>
+        <p:txBody>
+          <a:bodyPr wrap="square" lIns="0" tIns="0" rIns="0" bIns="0" rtlCol="0" anchor="ctr"/>
+          <a:lstStyle/>
+          <a:p>
+            <a:pPr algn="ctr" indent="0" marL="0">
+              <a:buNone/>
+            </a:pPr>
+            <a:r>
+              <a:rPr lang="en-US" sz="1500" b="1" dirty="0">
+                <a:solidFill>
+                  <a:srgbClr val="1C1F26"/>
+                </a:solidFill>
+                <a:latin typeface="Calibri" pitchFamily="34" charset="0"/>
+                <a:ea typeface="Calibri" pitchFamily="34" charset="-122"/>
+                <a:cs typeface="Calibri" pitchFamily="34" charset="-120"/>
+              </a:rPr>
+              <a:t>Difusión</a:t>
+            </a:r>
+            <a:endParaRPr lang="en-US" sz="1500" dirty="0"/>
+          </a:p>
+          <a:p>
+            <a:pPr algn="ctr" indent="0" marL="0">
+              <a:buNone/>
+            </a:pPr>
+            <a:r>
+              <a:rPr lang="en-US" sz="1500" b="1" dirty="0">
+                <a:solidFill>
+                  <a:srgbClr val="1C1F26"/>
+                </a:solidFill>
+                <a:latin typeface="Calibri" pitchFamily="34" charset="0"/>
+                <a:ea typeface="Calibri" pitchFamily="34" charset="-122"/>
+                <a:cs typeface="Calibri" pitchFamily="34" charset="-120"/>
+              </a:rPr>
+              <a:t>discreta</a:t>
+            </a:r>
+            <a:endParaRPr lang="en-US" sz="1500" dirty="0"/>
+          </a:p>
+        </p:txBody>
+      </p:sp>
+      <p:sp>
+        <p:nvSpPr>
+          <p:cNvPr id="9" name="Text 6"/>
+          <p:cNvSpPr/>
+          <p:nvPr/>
+        </p:nvSpPr>
+        <p:spPr>
+          <a:xfrm>
+            <a:off x="1463040" y="4251960"/>
+            <a:ext cx="2651760" cy="365760"/>
+          </a:xfrm>
+          <a:prstGeom prst="rect">
+            <a:avLst/>
+          </a:prstGeom>
+          <a:noFill/>
+          <a:ln/>
+        </p:spPr>
+        <p:txBody>
+          <a:bodyPr wrap="square" lIns="0" tIns="0" rIns="0" bIns="0" rtlCol="0" anchor="ctr"/>
+          <a:lstStyle/>
+          <a:p>
+            <a:pPr algn="ctr" indent="0" marL="0">
+              <a:buNone/>
+            </a:pPr>
+            <a:r>
+              <a:rPr lang="en-US" sz="1250" i="1" dirty="0">
+                <a:solidFill>
+                  <a:srgbClr val="6B6B66"/>
+                </a:solidFill>
+                <a:latin typeface="Calibri" pitchFamily="34" charset="0"/>
+                <a:ea typeface="Calibri" pitchFamily="34" charset="-122"/>
+                <a:cs typeface="Calibri" pitchFamily="34" charset="-120"/>
+              </a:rPr>
+              <a:t>Descubrir</a:t>
+            </a:r>
+            <a:endParaRPr lang="en-US" sz="1250" dirty="0"/>
+          </a:p>
+        </p:txBody>
       </p:sp>
       <p:pic>
         <p:nvPicPr>
-          <p:cNvPr id="8" name="Image 1" descr="/tmp/hosty56_build/icons/bullhorn_charcoal.png">    </p:cNvPr>
+          <p:cNvPr id="10" name="Image 1" descr="/tmp/hosty56_build/icons/arrowRight_charcoal.png">    </p:cNvPr>
           <p:cNvPicPr>
             <a:picLocks noChangeAspect="1"/>
           </p:cNvPicPr>
@@ -9285,8 +8950,8 @@
         </p:blipFill>
         <p:spPr>
           <a:xfrm>
-            <a:off x="745693" y="2437333"/>
-            <a:ext cx="291694" cy="291694"/>
+            <a:off x="4261104" y="2926080"/>
+            <a:ext cx="320040" cy="320040"/>
           </a:xfrm>
           <a:prstGeom prst="rect">
             <a:avLst/>
@@ -9295,105 +8960,66 @@
       </p:pic>
       <p:sp>
         <p:nvSpPr>
-          <p:cNvPr id="9" name="Text 5"/>
-          <p:cNvSpPr/>
-          <p:nvPr/>
-        </p:nvSpPr>
-        <p:spPr>
-          <a:xfrm>
-            <a:off x="1371600" y="2286000"/>
-            <a:ext cx="9326880" cy="365760"/>
-          </a:xfrm>
-          <a:prstGeom prst="rect">
-            <a:avLst/>
-          </a:prstGeom>
-          <a:noFill/>
-          <a:ln/>
-        </p:spPr>
-        <p:txBody>
-          <a:bodyPr wrap="square" lIns="0" tIns="0" rIns="0" bIns="0" rtlCol="0" anchor="ctr"/>
-          <a:lstStyle/>
-          <a:p>
-            <a:pPr indent="0" marL="0">
-              <a:buNone/>
-            </a:pPr>
-            <a:r>
-              <a:rPr lang="en-US" sz="1600" b="1" dirty="0">
-                <a:solidFill>
-                  <a:srgbClr val="1C1F26"/>
-                </a:solidFill>
-                <a:latin typeface="Calibri" pitchFamily="34" charset="0"/>
-                <a:ea typeface="Calibri" pitchFamily="34" charset="-122"/>
-                <a:cs typeface="Calibri" pitchFamily="34" charset="-120"/>
-              </a:rPr>
-              <a:t>Meta Ads tipo teaser</a:t>
-            </a:r>
-            <a:endParaRPr lang="en-US" sz="1600" dirty="0"/>
-          </a:p>
-        </p:txBody>
-      </p:sp>
-      <p:sp>
-        <p:nvSpPr>
-          <p:cNvPr id="10" name="Text 6"/>
-          <p:cNvSpPr/>
-          <p:nvPr/>
-        </p:nvSpPr>
-        <p:spPr>
-          <a:xfrm>
-            <a:off x="1371600" y="2679192"/>
-            <a:ext cx="9326880" cy="685800"/>
-          </a:xfrm>
-          <a:prstGeom prst="rect">
-            <a:avLst/>
-          </a:prstGeom>
-          <a:noFill/>
-          <a:ln/>
-        </p:spPr>
-        <p:txBody>
-          <a:bodyPr wrap="square" lIns="0" tIns="0" rIns="0" bIns="0" rtlCol="0" anchor="ctr"/>
-          <a:lstStyle/>
-          <a:p>
-            <a:pPr indent="0" marL="0">
-              <a:buNone/>
-            </a:pPr>
-            <a:r>
-              <a:rPr lang="en-US" sz="1350" dirty="0">
-                <a:solidFill>
-                  <a:srgbClr val="6B6B66"/>
-                </a:solidFill>
-                <a:latin typeface="Calibri" pitchFamily="34" charset="0"/>
-                <a:ea typeface="Calibri" pitchFamily="34" charset="-122"/>
-                <a:cs typeface="Calibri" pitchFamily="34" charset="-120"/>
-              </a:rPr>
-              <a:t>Edificio de renta corta en operación en Bogotá, facturación de 8 cifras mensuales — sin dirección ni cifras exactas.</a:t>
-            </a:r>
-            <a:endParaRPr lang="en-US" sz="1350" dirty="0"/>
-          </a:p>
-        </p:txBody>
-      </p:sp>
-      <p:sp>
-        <p:nvSpPr>
-          <p:cNvPr id="11" name="Shape 7"/>
-          <p:cNvSpPr/>
-          <p:nvPr/>
-        </p:nvSpPr>
-        <p:spPr>
-          <a:xfrm>
-            <a:off x="640080" y="3566160"/>
-            <a:ext cx="502920" cy="502920"/>
+          <p:cNvPr id="11" name="Text 7"/>
+          <p:cNvSpPr/>
+          <p:nvPr/>
+        </p:nvSpPr>
+        <p:spPr>
+          <a:xfrm>
+            <a:off x="4754880" y="2240280"/>
+            <a:ext cx="2651760" cy="457200"/>
+          </a:xfrm>
+          <a:prstGeom prst="rect">
+            <a:avLst/>
+          </a:prstGeom>
+          <a:noFill/>
+          <a:ln/>
+        </p:spPr>
+        <p:txBody>
+          <a:bodyPr wrap="square" lIns="0" tIns="0" rIns="0" bIns="0" rtlCol="0" anchor="ctr"/>
+          <a:lstStyle/>
+          <a:p>
+            <a:pPr indent="0" marL="0">
+              <a:buNone/>
+            </a:pPr>
+            <a:r>
+              <a:rPr lang="en-US" sz="2000" b="1" dirty="0">
+                <a:solidFill>
+                  <a:srgbClr val="B08D57"/>
+                </a:solidFill>
+                <a:latin typeface="Cambria" pitchFamily="34" charset="0"/>
+                <a:ea typeface="Cambria" pitchFamily="34" charset="-122"/>
+                <a:cs typeface="Cambria" pitchFamily="34" charset="-120"/>
+              </a:rPr>
+              <a:t>02</a:t>
+            </a:r>
+            <a:endParaRPr lang="en-US" sz="2000" dirty="0"/>
+          </a:p>
+        </p:txBody>
+      </p:sp>
+      <p:sp>
+        <p:nvSpPr>
+          <p:cNvPr id="12" name="Shape 8"/>
+          <p:cNvSpPr/>
+          <p:nvPr/>
+        </p:nvSpPr>
+        <p:spPr>
+          <a:xfrm>
+            <a:off x="5715000" y="2743200"/>
+            <a:ext cx="731520" cy="731520"/>
           </a:xfrm>
           <a:prstGeom prst="ellipse">
             <a:avLst/>
           </a:prstGeom>
           <a:solidFill>
-            <a:srgbClr val="F2F1EE"/>
+            <a:srgbClr val="1C1F26"/>
           </a:solidFill>
           <a:ln/>
         </p:spPr>
       </p:sp>
       <p:pic>
         <p:nvPicPr>
-          <p:cNvPr id="12" name="Image 2" descr="/tmp/hosty56_build/icons/globe_charcoal.png">    </p:cNvPr>
+          <p:cNvPr id="13" name="Image 2" descr="/tmp/hosty56_build/icons/filter_gold.png">    </p:cNvPr>
           <p:cNvPicPr>
             <a:picLocks noChangeAspect="1"/>
           </p:cNvPicPr>
@@ -9407,8 +9033,8 @@
         </p:blipFill>
         <p:spPr>
           <a:xfrm>
-            <a:off x="745693" y="3671773"/>
-            <a:ext cx="291694" cy="291694"/>
+            <a:off x="5868619" y="2896819"/>
+            <a:ext cx="424282" cy="424282"/>
           </a:xfrm>
           <a:prstGeom prst="rect">
             <a:avLst/>
@@ -9417,30 +9043,30 @@
       </p:pic>
       <p:sp>
         <p:nvSpPr>
-          <p:cNvPr id="13" name="Text 8"/>
-          <p:cNvSpPr/>
-          <p:nvPr/>
-        </p:nvSpPr>
-        <p:spPr>
-          <a:xfrm>
-            <a:off x="1371600" y="3520440"/>
-            <a:ext cx="9326880" cy="365760"/>
-          </a:xfrm>
-          <a:prstGeom prst="rect">
-            <a:avLst/>
-          </a:prstGeom>
-          <a:noFill/>
-          <a:ln/>
-        </p:spPr>
-        <p:txBody>
-          <a:bodyPr wrap="square" lIns="0" tIns="0" rIns="0" bIns="0" rtlCol="0" anchor="ctr"/>
-          <a:lstStyle/>
-          <a:p>
-            <a:pPr indent="0" marL="0">
-              <a:buNone/>
-            </a:pPr>
-            <a:r>
-              <a:rPr lang="en-US" sz="1600" b="1" dirty="0">
+          <p:cNvPr id="14" name="Text 9"/>
+          <p:cNvSpPr/>
+          <p:nvPr/>
+        </p:nvSpPr>
+        <p:spPr>
+          <a:xfrm>
+            <a:off x="4754880" y="3657600"/>
+            <a:ext cx="2651760" cy="640080"/>
+          </a:xfrm>
+          <a:prstGeom prst="rect">
+            <a:avLst/>
+          </a:prstGeom>
+          <a:noFill/>
+          <a:ln/>
+        </p:spPr>
+        <p:txBody>
+          <a:bodyPr wrap="square" lIns="0" tIns="0" rIns="0" bIns="0" rtlCol="0" anchor="ctr"/>
+          <a:lstStyle/>
+          <a:p>
+            <a:pPr algn="ctr" indent="0" marL="0">
+              <a:buNone/>
+            </a:pPr>
+            <a:r>
+              <a:rPr lang="en-US" sz="1500" b="1" dirty="0">
                 <a:solidFill>
                   <a:srgbClr val="1C1F26"/>
                 </a:solidFill>
@@ -9448,38 +9074,55 @@
                 <a:ea typeface="Calibri" pitchFamily="34" charset="-122"/>
                 <a:cs typeface="Calibri" pitchFamily="34" charset="-120"/>
               </a:rPr>
-              <a:t>Segmentación</a:t>
-            </a:r>
-            <a:endParaRPr lang="en-US" sz="1600" dirty="0"/>
-          </a:p>
-        </p:txBody>
-      </p:sp>
-      <p:sp>
-        <p:nvSpPr>
-          <p:cNvPr id="14" name="Text 9"/>
-          <p:cNvSpPr/>
-          <p:nvPr/>
-        </p:nvSpPr>
-        <p:spPr>
-          <a:xfrm>
-            <a:off x="1371600" y="3913632"/>
-            <a:ext cx="9326880" cy="685800"/>
-          </a:xfrm>
-          <a:prstGeom prst="rect">
-            <a:avLst/>
-          </a:prstGeom>
-          <a:noFill/>
-          <a:ln/>
-        </p:spPr>
-        <p:txBody>
-          <a:bodyPr wrap="square" lIns="0" tIns="0" rIns="0" bIns="0" rtlCol="0" anchor="ctr"/>
-          <a:lstStyle/>
-          <a:p>
-            <a:pPr indent="0" marL="0">
-              <a:buNone/>
-            </a:pPr>
-            <a:r>
-              <a:rPr lang="en-US" sz="1350" dirty="0">
+              <a:t>Calificación</a:t>
+            </a:r>
+            <a:endParaRPr lang="en-US" sz="1500" dirty="0"/>
+          </a:p>
+          <a:p>
+            <a:pPr algn="ctr" indent="0" marL="0">
+              <a:buNone/>
+            </a:pPr>
+            <a:r>
+              <a:rPr lang="en-US" sz="1500" b="1" dirty="0">
+                <a:solidFill>
+                  <a:srgbClr val="1C1F26"/>
+                </a:solidFill>
+                <a:latin typeface="Calibri" pitchFamily="34" charset="0"/>
+                <a:ea typeface="Calibri" pitchFamily="34" charset="-122"/>
+                <a:cs typeface="Calibri" pitchFamily="34" charset="-120"/>
+              </a:rPr>
+              <a:t>digital</a:t>
+            </a:r>
+            <a:endParaRPr lang="en-US" sz="1500" dirty="0"/>
+          </a:p>
+        </p:txBody>
+      </p:sp>
+      <p:sp>
+        <p:nvSpPr>
+          <p:cNvPr id="15" name="Text 10"/>
+          <p:cNvSpPr/>
+          <p:nvPr/>
+        </p:nvSpPr>
+        <p:spPr>
+          <a:xfrm>
+            <a:off x="4754880" y="4251960"/>
+            <a:ext cx="2651760" cy="365760"/>
+          </a:xfrm>
+          <a:prstGeom prst="rect">
+            <a:avLst/>
+          </a:prstGeom>
+          <a:noFill/>
+          <a:ln/>
+        </p:spPr>
+        <p:txBody>
+          <a:bodyPr wrap="square" lIns="0" tIns="0" rIns="0" bIns="0" rtlCol="0" anchor="ctr"/>
+          <a:lstStyle/>
+          <a:p>
+            <a:pPr algn="ctr" indent="0" marL="0">
+              <a:buNone/>
+            </a:pPr>
+            <a:r>
+              <a:rPr lang="en-US" sz="1250" i="1" dirty="0">
                 <a:solidFill>
                   <a:srgbClr val="6B6B66"/>
                 </a:solidFill>
@@ -9487,35 +9130,15 @@
                 <a:ea typeface="Calibri" pitchFamily="34" charset="-122"/>
                 <a:cs typeface="Calibri" pitchFamily="34" charset="-120"/>
               </a:rPr>
-              <a:t>Interés en inversión inmobiliaria, alto patrimonio, hospitality y renta corta, fondos de inversión.</a:t>
-            </a:r>
-            <a:endParaRPr lang="en-US" sz="1350" dirty="0"/>
-          </a:p>
-        </p:txBody>
-      </p:sp>
-      <p:sp>
-        <p:nvSpPr>
-          <p:cNvPr id="15" name="Shape 10"/>
-          <p:cNvSpPr/>
-          <p:nvPr/>
-        </p:nvSpPr>
-        <p:spPr>
-          <a:xfrm>
-            <a:off x="640080" y="4800600"/>
-            <a:ext cx="502920" cy="502920"/>
-          </a:xfrm>
-          <a:prstGeom prst="ellipse">
-            <a:avLst/>
-          </a:prstGeom>
-          <a:solidFill>
-            <a:srgbClr val="F2F1EE"/>
-          </a:solidFill>
-          <a:ln/>
-        </p:spPr>
+              <a:t>Filtrar</a:t>
+            </a:r>
+            <a:endParaRPr lang="en-US" sz="1250" dirty="0"/>
+          </a:p>
+        </p:txBody>
       </p:sp>
       <p:pic>
         <p:nvPicPr>
-          <p:cNvPr id="16" name="Image 3" descr="/tmp/hosty56_build/icons/filter_charcoal.png">    </p:cNvPr>
+          <p:cNvPr id="16" name="Image 3" descr="/tmp/hosty56_build/icons/arrowRight_charcoal.png">    </p:cNvPr>
           <p:cNvPicPr>
             <a:picLocks noChangeAspect="1"/>
           </p:cNvPicPr>
@@ -9529,8 +9152,8 @@
         </p:blipFill>
         <p:spPr>
           <a:xfrm>
-            <a:off x="745693" y="4906213"/>
-            <a:ext cx="291694" cy="291694"/>
+            <a:off x="7552944" y="2926080"/>
+            <a:ext cx="320040" cy="320040"/>
           </a:xfrm>
           <a:prstGeom prst="rect">
             <a:avLst/>
@@ -9545,24 +9168,107 @@
         </p:nvSpPr>
         <p:spPr>
           <a:xfrm>
-            <a:off x="1371600" y="4754880"/>
-            <a:ext cx="9326880" cy="365760"/>
-          </a:xfrm>
-          <a:prstGeom prst="rect">
-            <a:avLst/>
-          </a:prstGeom>
-          <a:noFill/>
-          <a:ln/>
-        </p:spPr>
-        <p:txBody>
-          <a:bodyPr wrap="square" lIns="0" tIns="0" rIns="0" bIns="0" rtlCol="0" anchor="ctr"/>
-          <a:lstStyle/>
-          <a:p>
-            <a:pPr indent="0" marL="0">
-              <a:buNone/>
-            </a:pPr>
-            <a:r>
-              <a:rPr lang="en-US" sz="1600" b="1" dirty="0">
+            <a:off x="8046720" y="2240280"/>
+            <a:ext cx="2651760" cy="457200"/>
+          </a:xfrm>
+          <a:prstGeom prst="rect">
+            <a:avLst/>
+          </a:prstGeom>
+          <a:noFill/>
+          <a:ln/>
+        </p:spPr>
+        <p:txBody>
+          <a:bodyPr wrap="square" lIns="0" tIns="0" rIns="0" bIns="0" rtlCol="0" anchor="ctr"/>
+          <a:lstStyle/>
+          <a:p>
+            <a:pPr indent="0" marL="0">
+              <a:buNone/>
+            </a:pPr>
+            <a:r>
+              <a:rPr lang="en-US" sz="2000" b="1" dirty="0">
+                <a:solidFill>
+                  <a:srgbClr val="B08D57"/>
+                </a:solidFill>
+                <a:latin typeface="Cambria" pitchFamily="34" charset="0"/>
+                <a:ea typeface="Cambria" pitchFamily="34" charset="-122"/>
+                <a:cs typeface="Cambria" pitchFamily="34" charset="-120"/>
+              </a:rPr>
+              <a:t>03</a:t>
+            </a:r>
+            <a:endParaRPr lang="en-US" sz="2000" dirty="0"/>
+          </a:p>
+        </p:txBody>
+      </p:sp>
+      <p:sp>
+        <p:nvSpPr>
+          <p:cNvPr id="18" name="Shape 12"/>
+          <p:cNvSpPr/>
+          <p:nvPr/>
+        </p:nvSpPr>
+        <p:spPr>
+          <a:xfrm>
+            <a:off x="9006840" y="2743200"/>
+            <a:ext cx="731520" cy="731520"/>
+          </a:xfrm>
+          <a:prstGeom prst="ellipse">
+            <a:avLst/>
+          </a:prstGeom>
+          <a:solidFill>
+            <a:srgbClr val="1C1F26"/>
+          </a:solidFill>
+          <a:ln/>
+        </p:spPr>
+      </p:sp>
+      <p:pic>
+        <p:nvPicPr>
+          <p:cNvPr id="19" name="Image 4" descr="/tmp/hosty56_build/icons/arrowRight_gold.png">    </p:cNvPr>
+          <p:cNvPicPr>
+            <a:picLocks noChangeAspect="1"/>
+          </p:cNvPicPr>
+          <p:nvPr/>
+        </p:nvPicPr>
+        <p:blipFill>
+          <a:blip r:embed="rId5"/>
+          <a:stretch>
+            <a:fillRect/>
+          </a:stretch>
+        </p:blipFill>
+        <p:spPr>
+          <a:xfrm>
+            <a:off x="9160459" y="2896819"/>
+            <a:ext cx="424282" cy="424282"/>
+          </a:xfrm>
+          <a:prstGeom prst="rect">
+            <a:avLst/>
+          </a:prstGeom>
+        </p:spPr>
+      </p:pic>
+      <p:sp>
+        <p:nvSpPr>
+          <p:cNvPr id="20" name="Text 13"/>
+          <p:cNvSpPr/>
+          <p:nvPr/>
+        </p:nvSpPr>
+        <p:spPr>
+          <a:xfrm>
+            <a:off x="8046720" y="3657600"/>
+            <a:ext cx="2651760" cy="640080"/>
+          </a:xfrm>
+          <a:prstGeom prst="rect">
+            <a:avLst/>
+          </a:prstGeom>
+          <a:noFill/>
+          <a:ln/>
+        </p:spPr>
+        <p:txBody>
+          <a:bodyPr wrap="square" lIns="0" tIns="0" rIns="0" bIns="0" rtlCol="0" anchor="ctr"/>
+          <a:lstStyle/>
+          <a:p>
+            <a:pPr algn="ctr" indent="0" marL="0">
+              <a:buNone/>
+            </a:pPr>
+            <a:r>
+              <a:rPr lang="en-US" sz="1500" b="1" dirty="0">
                 <a:solidFill>
                   <a:srgbClr val="1C1F26"/>
                 </a:solidFill>
@@ -9570,38 +9276,55 @@
                 <a:ea typeface="Calibri" pitchFamily="34" charset="-122"/>
                 <a:cs typeface="Calibri" pitchFamily="34" charset="-120"/>
               </a:rPr>
-              <a:t>Métrica de éxito</a:t>
-            </a:r>
-            <a:endParaRPr lang="en-US" sz="1600" dirty="0"/>
-          </a:p>
-        </p:txBody>
-      </p:sp>
-      <p:sp>
-        <p:nvSpPr>
-          <p:cNvPr id="18" name="Text 12"/>
-          <p:cNvSpPr/>
-          <p:nvPr/>
-        </p:nvSpPr>
-        <p:spPr>
-          <a:xfrm>
-            <a:off x="1371600" y="5148072"/>
-            <a:ext cx="9326880" cy="685800"/>
-          </a:xfrm>
-          <a:prstGeom prst="rect">
-            <a:avLst/>
-          </a:prstGeom>
-          <a:noFill/>
-          <a:ln/>
-        </p:spPr>
-        <p:txBody>
-          <a:bodyPr wrap="square" lIns="0" tIns="0" rIns="0" bIns="0" rtlCol="0" anchor="ctr"/>
-          <a:lstStyle/>
-          <a:p>
-            <a:pPr indent="0" marL="0">
-              <a:buNone/>
-            </a:pPr>
-            <a:r>
-              <a:rPr lang="en-US" sz="1350" dirty="0">
+              <a:t>Entrega de</a:t>
+            </a:r>
+            <a:endParaRPr lang="en-US" sz="1500" dirty="0"/>
+          </a:p>
+          <a:p>
+            <a:pPr algn="ctr" indent="0" marL="0">
+              <a:buNone/>
+            </a:pPr>
+            <a:r>
+              <a:rPr lang="en-US" sz="1500" b="1" dirty="0">
+                <a:solidFill>
+                  <a:srgbClr val="1C1F26"/>
+                </a:solidFill>
+                <a:latin typeface="Calibri" pitchFamily="34" charset="0"/>
+                <a:ea typeface="Calibri" pitchFamily="34" charset="-122"/>
+                <a:cs typeface="Calibri" pitchFamily="34" charset="-120"/>
+              </a:rPr>
+              <a:t>interesados</a:t>
+            </a:r>
+            <a:endParaRPr lang="en-US" sz="1500" dirty="0"/>
+          </a:p>
+        </p:txBody>
+      </p:sp>
+      <p:sp>
+        <p:nvSpPr>
+          <p:cNvPr id="21" name="Text 14"/>
+          <p:cNvSpPr/>
+          <p:nvPr/>
+        </p:nvSpPr>
+        <p:spPr>
+          <a:xfrm>
+            <a:off x="8046720" y="4251960"/>
+            <a:ext cx="2651760" cy="365760"/>
+          </a:xfrm>
+          <a:prstGeom prst="rect">
+            <a:avLst/>
+          </a:prstGeom>
+          <a:noFill/>
+          <a:ln/>
+        </p:spPr>
+        <p:txBody>
+          <a:bodyPr wrap="square" lIns="0" tIns="0" rIns="0" bIns="0" rtlCol="0" anchor="ctr"/>
+          <a:lstStyle/>
+          <a:p>
+            <a:pPr algn="ctr" indent="0" marL="0">
+              <a:buNone/>
+            </a:pPr>
+            <a:r>
+              <a:rPr lang="en-US" sz="1250" i="1" dirty="0">
                 <a:solidFill>
                   <a:srgbClr val="6B6B66"/>
                 </a:solidFill>
@@ -9609,15 +9332,54 @@
                 <a:ea typeface="Calibri" pitchFamily="34" charset="-122"/>
                 <a:cs typeface="Calibri" pitchFamily="34" charset="-120"/>
               </a:rPr>
-              <a:t>Leads calificados que dejan datos de contacto, no likes ni alcance masivo.</a:t>
-            </a:r>
-            <a:endParaRPr lang="en-US" sz="1350" dirty="0"/>
-          </a:p>
-        </p:txBody>
-      </p:sp>
-      <p:sp>
-        <p:nvSpPr>
-          <p:cNvPr id="19" name="Text 13"/>
+              <a:t>Traspasar</a:t>
+            </a:r>
+            <a:endParaRPr lang="en-US" sz="1250" dirty="0"/>
+          </a:p>
+        </p:txBody>
+      </p:sp>
+      <p:sp>
+        <p:nvSpPr>
+          <p:cNvPr id="22" name="Text 15"/>
+          <p:cNvSpPr/>
+          <p:nvPr/>
+        </p:nvSpPr>
+        <p:spPr>
+          <a:xfrm>
+            <a:off x="640080" y="5486400"/>
+            <a:ext cx="10698480" cy="548640"/>
+          </a:xfrm>
+          <a:prstGeom prst="rect">
+            <a:avLst/>
+          </a:prstGeom>
+          <a:noFill/>
+          <a:ln/>
+        </p:spPr>
+        <p:txBody>
+          <a:bodyPr wrap="square" lIns="0" tIns="0" rIns="0" bIns="0" rtlCol="0" anchor="ctr"/>
+          <a:lstStyle/>
+          <a:p>
+            <a:pPr indent="0" marL="0">
+              <a:buNone/>
+            </a:pPr>
+            <a:r>
+              <a:rPr lang="en-US" sz="1450" i="1" dirty="0">
+                <a:solidFill>
+                  <a:srgbClr val="1C1F26"/>
+                </a:solidFill>
+                <a:latin typeface="Calibri" pitchFamily="34" charset="0"/>
+                <a:ea typeface="Calibri" pitchFamily="34" charset="-122"/>
+                <a:cs typeface="Calibri" pitchFamily="34" charset="-120"/>
+              </a:rPr>
+              <a:t>El resultado no es una lista de curiosos: son contactos reales, calificados, listos para que ustedes avancen con ellos.</a:t>
+            </a:r>
+            <a:endParaRPr lang="en-US" sz="1450" dirty="0"/>
+          </a:p>
+        </p:txBody>
+      </p:sp>
+      <p:sp>
+        <p:nvSpPr>
+          <p:cNvPr id="23" name="Text 16"/>
           <p:cNvSpPr/>
           <p:nvPr/>
         </p:nvSpPr>
@@ -9719,7 +9481,7 @@
                 <a:ea typeface="Calibri" pitchFamily="34" charset="-122"/>
                 <a:cs typeface="Calibri" pitchFamily="34" charset="-120"/>
               </a:rPr>
-              <a:t>ETAPA 02</a:t>
+              <a:t>ETAPA 01</a:t>
             </a:r>
             <a:endParaRPr lang="en-US" sz="1300" dirty="0"/>
           </a:p>
@@ -9734,23 +9496,23 @@
         <p:spPr>
           <a:xfrm>
             <a:off x="640080" y="777240"/>
-            <a:ext cx="7315200" cy="731520"/>
-          </a:xfrm>
-          <a:prstGeom prst="rect">
-            <a:avLst/>
-          </a:prstGeom>
-          <a:noFill/>
-          <a:ln/>
-        </p:spPr>
-        <p:txBody>
-          <a:bodyPr wrap="square" lIns="0" tIns="0" rIns="0" bIns="0" rtlCol="0" anchor="ctr"/>
-          <a:lstStyle/>
-          <a:p>
-            <a:pPr indent="0" marL="0">
-              <a:buNone/>
-            </a:pPr>
-            <a:r>
-              <a:rPr lang="en-US" sz="3200" b="1" dirty="0">
+            <a:ext cx="8229600" cy="731520"/>
+          </a:xfrm>
+          <a:prstGeom prst="rect">
+            <a:avLst/>
+          </a:prstGeom>
+          <a:noFill/>
+          <a:ln/>
+        </p:spPr>
+        <p:txBody>
+          <a:bodyPr wrap="square" lIns="0" tIns="0" rIns="0" bIns="0" rtlCol="0" anchor="ctr"/>
+          <a:lstStyle/>
+          <a:p>
+            <a:pPr indent="0" marL="0">
+              <a:buNone/>
+            </a:pPr>
+            <a:r>
+              <a:rPr lang="en-US" sz="3000" b="1" dirty="0">
                 <a:solidFill>
                   <a:srgbClr val="1C1F26"/>
                 </a:solidFill>
@@ -9758,9 +9520,9 @@
                 <a:ea typeface="Cambria" pitchFamily="34" charset="-122"/>
                 <a:cs typeface="Cambria" pitchFamily="34" charset="-120"/>
               </a:rPr>
-              <a:t>Calificación con NDA</a:t>
-            </a:r>
-            <a:endParaRPr lang="en-US" sz="3200" dirty="0"/>
+              <a:t>Difusión discreta</a:t>
+            </a:r>
+            <a:endParaRPr lang="en-US" sz="3000" dirty="0"/>
           </a:p>
         </p:txBody>
       </p:sp>
@@ -9797,7 +9559,7 @@
                 <a:ea typeface="Calibri" pitchFamily="34" charset="-122"/>
                 <a:cs typeface="Calibri" pitchFamily="34" charset="-120"/>
               </a:rPr>
-              <a:t>Objetivo: filtrar curiosos antes de compartir información confidencial.</a:t>
+              <a:t>Objetivo: generar interés calificado en Meta Ads, sin exponer datos sensibles.</a:t>
             </a:r>
             <a:endParaRPr lang="en-US" sz="1500" dirty="0"/>
           </a:p>
@@ -9825,7 +9587,7 @@
       </p:sp>
       <p:pic>
         <p:nvPicPr>
-          <p:cNvPr id="6" name="Image 0" descr="/tmp/hosty56_build/icons/fileSignature_gold.png">    </p:cNvPr>
+          <p:cNvPr id="6" name="Image 0" descr="/tmp/hosty56_build/icons/eye_gold.png">    </p:cNvPr>
           <p:cNvPicPr>
             <a:picLocks noChangeAspect="1"/>
           </p:cNvPicPr>
@@ -9869,7 +9631,7 @@
       </p:sp>
       <p:pic>
         <p:nvPicPr>
-          <p:cNvPr id="8" name="Image 1" descr="/tmp/hosty56_build/icons/lock_charcoal.png">    </p:cNvPr>
+          <p:cNvPr id="8" name="Image 1" descr="/tmp/hosty56_build/icons/bullhorn_charcoal.png">    </p:cNvPr>
           <p:cNvPicPr>
             <a:picLocks noChangeAspect="1"/>
           </p:cNvPicPr>
@@ -9924,7 +9686,7 @@
                 <a:ea typeface="Calibri" pitchFamily="34" charset="-122"/>
                 <a:cs typeface="Calibri" pitchFamily="34" charset="-120"/>
               </a:rPr>
-              <a:t>Landing de calificación</a:t>
+              <a:t>Meta Ads tipo teaser</a:t>
             </a:r>
             <a:endParaRPr lang="en-US" sz="1600" dirty="0"/>
           </a:p>
@@ -9963,7 +9725,7 @@
                 <a:ea typeface="Calibri" pitchFamily="34" charset="-122"/>
                 <a:cs typeface="Calibri" pitchFamily="34" charset="-120"/>
               </a:rPr>
-              <a:t>El interesado responde preguntas de capacidad financiera y tipo de comprador antes de continuar.</a:t>
+              <a:t>Edificio de renta corta en operación en Bogotá, facturación de 8 cifras mensuales — sin dirección ni cifras exactas.</a:t>
             </a:r>
             <a:endParaRPr lang="en-US" sz="1350" dirty="0"/>
           </a:p>
@@ -9991,7 +9753,7 @@
       </p:sp>
       <p:pic>
         <p:nvPicPr>
-          <p:cNvPr id="12" name="Image 2" descr="/tmp/hosty56_build/icons/fileSignature_charcoal.png">    </p:cNvPr>
+          <p:cNvPr id="12" name="Image 2" descr="/tmp/hosty56_build/icons/globe_charcoal.png">    </p:cNvPr>
           <p:cNvPicPr>
             <a:picLocks noChangeAspect="1"/>
           </p:cNvPicPr>
@@ -10046,7 +9808,7 @@
                 <a:ea typeface="Calibri" pitchFamily="34" charset="-122"/>
                 <a:cs typeface="Calibri" pitchFamily="34" charset="-120"/>
               </a:rPr>
-              <a:t>NDA digital</a:t>
+              <a:t>Segmentación</a:t>
             </a:r>
             <a:endParaRPr lang="en-US" sz="1600" dirty="0"/>
           </a:p>
@@ -10085,7 +9847,7 @@
                 <a:ea typeface="Calibri" pitchFamily="34" charset="-122"/>
                 <a:cs typeface="Calibri" pitchFamily="34" charset="-120"/>
               </a:rPr>
-              <a:t>Solo quien firma el acuerdo de confidencialidad recibe el dossier completo.</a:t>
+              <a:t>Interés en inversión inmobiliaria, alto patrimonio, hospitality y renta corta, fondos de inversión.</a:t>
             </a:r>
             <a:endParaRPr lang="en-US" sz="1350" dirty="0"/>
           </a:p>
@@ -10113,7 +9875,7 @@
       </p:sp>
       <p:pic>
         <p:nvPicPr>
-          <p:cNvPr id="16" name="Image 3" descr="/tmp/hosty56_build/icons/checkCircle_charcoal.png">    </p:cNvPr>
+          <p:cNvPr id="16" name="Image 3" descr="/tmp/hosty56_build/icons/chart_charcoal.png">    </p:cNvPr>
           <p:cNvPicPr>
             <a:picLocks noChangeAspect="1"/>
           </p:cNvPicPr>
@@ -10168,7 +9930,7 @@
                 <a:ea typeface="Calibri" pitchFamily="34" charset="-122"/>
                 <a:cs typeface="Calibri" pitchFamily="34" charset="-120"/>
               </a:rPr>
-              <a:t>Dossier confidencial</a:t>
+              <a:t>Métrica de éxito</a:t>
             </a:r>
             <a:endParaRPr lang="en-US" sz="1600" dirty="0"/>
           </a:p>
@@ -10207,7 +9969,7 @@
                 <a:ea typeface="Calibri" pitchFamily="34" charset="-122"/>
                 <a:cs typeface="Calibri" pitchFamily="34" charset="-120"/>
               </a:rPr>
-              <a:t>Dirección, fotos, estado financiero y situación legal — entregado únicamente a calificados.</a:t>
+              <a:t>Interesados que completan el formulario de calificación, no likes ni alcance masivo.</a:t>
             </a:r>
             <a:endParaRPr lang="en-US" sz="1350" dirty="0"/>
           </a:p>
@@ -10317,7 +10079,7 @@
                 <a:ea typeface="Calibri" pitchFamily="34" charset="-122"/>
                 <a:cs typeface="Calibri" pitchFamily="34" charset="-120"/>
               </a:rPr>
-              <a:t>ETAPA 03</a:t>
+              <a:t>ETAPA 02</a:t>
             </a:r>
             <a:endParaRPr lang="en-US" sz="1300" dirty="0"/>
           </a:p>
@@ -10332,23 +10094,23 @@
         <p:spPr>
           <a:xfrm>
             <a:off x="640080" y="777240"/>
-            <a:ext cx="7315200" cy="731520"/>
-          </a:xfrm>
-          <a:prstGeom prst="rect">
-            <a:avLst/>
-          </a:prstGeom>
-          <a:noFill/>
-          <a:ln/>
-        </p:spPr>
-        <p:txBody>
-          <a:bodyPr wrap="square" lIns="0" tIns="0" rIns="0" bIns="0" rtlCol="0" anchor="ctr"/>
-          <a:lstStyle/>
-          <a:p>
-            <a:pPr indent="0" marL="0">
-              <a:buNone/>
-            </a:pPr>
-            <a:r>
-              <a:rPr lang="en-US" sz="3200" b="1" dirty="0">
+            <a:ext cx="8229600" cy="731520"/>
+          </a:xfrm>
+          <a:prstGeom prst="rect">
+            <a:avLst/>
+          </a:prstGeom>
+          <a:noFill/>
+          <a:ln/>
+        </p:spPr>
+        <p:txBody>
+          <a:bodyPr wrap="square" lIns="0" tIns="0" rIns="0" bIns="0" rtlCol="0" anchor="ctr"/>
+          <a:lstStyle/>
+          <a:p>
+            <a:pPr indent="0" marL="0">
+              <a:buNone/>
+            </a:pPr>
+            <a:r>
+              <a:rPr lang="en-US" sz="3000" b="1" dirty="0">
                 <a:solidFill>
                   <a:srgbClr val="1C1F26"/>
                 </a:solidFill>
@@ -10356,9 +10118,9 @@
                 <a:ea typeface="Cambria" pitchFamily="34" charset="-122"/>
                 <a:cs typeface="Cambria" pitchFamily="34" charset="-120"/>
               </a:rPr>
-              <a:t>Llamada de interés</a:t>
-            </a:r>
-            <a:endParaRPr lang="en-US" sz="3200" dirty="0"/>
+              <a:t>Calificación digital</a:t>
+            </a:r>
+            <a:endParaRPr lang="en-US" sz="3000" dirty="0"/>
           </a:p>
         </p:txBody>
       </p:sp>
@@ -10395,7 +10157,7 @@
                 <a:ea typeface="Calibri" pitchFamily="34" charset="-122"/>
                 <a:cs typeface="Calibri" pitchFamily="34" charset="-120"/>
               </a:rPr>
-              <a:t>Objetivo: confirmar capacidad e interés real antes de agendar una visita.</a:t>
+              <a:t>Objetivo: filtrar curiosos automáticamente, antes de que lleguen a los propietarios.</a:t>
             </a:r>
             <a:endParaRPr lang="en-US" sz="1500" dirty="0"/>
           </a:p>
@@ -10423,7 +10185,7 @@
       </p:sp>
       <p:pic>
         <p:nvPicPr>
-          <p:cNvPr id="6" name="Image 0" descr="/tmp/hosty56_build/icons/phone_gold.png">    </p:cNvPr>
+          <p:cNvPr id="6" name="Image 0" descr="/tmp/hosty56_build/icons/filter_gold.png">    </p:cNvPr>
           <p:cNvPicPr>
             <a:picLocks noChangeAspect="1"/>
           </p:cNvPicPr>
@@ -10467,7 +10229,7 @@
       </p:sp>
       <p:pic>
         <p:nvPicPr>
-          <p:cNvPr id="8" name="Image 1" descr="/tmp/hosty56_build/icons/phone_charcoal.png">    </p:cNvPr>
+          <p:cNvPr id="8" name="Image 1" descr="/tmp/hosty56_build/icons/fileSignature_charcoal.png">    </p:cNvPr>
           <p:cNvPicPr>
             <a:picLocks noChangeAspect="1"/>
           </p:cNvPicPr>
@@ -10522,7 +10284,7 @@
                 <a:ea typeface="Calibri" pitchFamily="34" charset="-122"/>
                 <a:cs typeface="Calibri" pitchFamily="34" charset="-120"/>
               </a:rPr>
-              <a:t>Screening call breve</a:t>
+              <a:t>Landing de calificación</a:t>
             </a:r>
             <a:endParaRPr lang="en-US" sz="1600" dirty="0"/>
           </a:p>
@@ -10561,7 +10323,7 @@
                 <a:ea typeface="Calibri" pitchFamily="34" charset="-122"/>
                 <a:cs typeface="Calibri" pitchFamily="34" charset="-120"/>
               </a:rPr>
-              <a:t>Una llamada corta para verificar seriedad, capacidad financiera y expectativas del interesado.</a:t>
+              <a:t>El interesado responde preguntas de capacidad financiera, tipo de comprador e interés real antes de dejar sus datos.</a:t>
             </a:r>
             <a:endParaRPr lang="en-US" sz="1350" dirty="0"/>
           </a:p>
@@ -10589,7 +10351,7 @@
       </p:sp>
       <p:pic>
         <p:nvPicPr>
-          <p:cNvPr id="12" name="Image 2" descr="/tmp/hosty56_build/icons/checkCircle_charcoal.png">    </p:cNvPr>
+          <p:cNvPr id="12" name="Image 2" descr="/tmp/hosty56_build/icons/filter_charcoal.png">    </p:cNvPr>
           <p:cNvPicPr>
             <a:picLocks noChangeAspect="1"/>
           </p:cNvPicPr>
@@ -10644,7 +10406,7 @@
                 <a:ea typeface="Calibri" pitchFamily="34" charset="-122"/>
                 <a:cs typeface="Calibri" pitchFamily="34" charset="-120"/>
               </a:rPr>
-              <a:t>Preguntas clave</a:t>
+              <a:t>Filtro automático</a:t>
             </a:r>
             <a:endParaRPr lang="en-US" sz="1600" dirty="0"/>
           </a:p>
@@ -10683,7 +10445,7 @@
                 <a:ea typeface="Calibri" pitchFamily="34" charset="-122"/>
                 <a:cs typeface="Calibri" pitchFamily="34" charset="-120"/>
               </a:rPr>
-              <a:t>¿Compra individual, en sociedad o a través de un fondo? ¿Con qué plazo y forma de pago cuenta?</a:t>
+              <a:t>Solo quien responde con señales reales de capacidad e interés se registra como interesado calificado.</a:t>
             </a:r>
             <a:endParaRPr lang="en-US" sz="1350" dirty="0"/>
           </a:p>
@@ -10711,7 +10473,7 @@
       </p:sp>
       <p:pic>
         <p:nvPicPr>
-          <p:cNvPr id="16" name="Image 3" descr="/tmp/hosty56_build/icons/filter_charcoal.png">    </p:cNvPr>
+          <p:cNvPr id="16" name="Image 3" descr="/tmp/hosty56_build/icons/lock_charcoal.png">    </p:cNvPr>
           <p:cNvPicPr>
             <a:picLocks noChangeAspect="1"/>
           </p:cNvPicPr>
@@ -10766,7 +10528,7 @@
                 <a:ea typeface="Calibri" pitchFamily="34" charset="-122"/>
                 <a:cs typeface="Calibri" pitchFamily="34" charset="-120"/>
               </a:rPr>
-              <a:t>Resultado</a:t>
+              <a:t>Sin datos sensibles</a:t>
             </a:r>
             <a:endParaRPr lang="en-US" sz="1600" dirty="0"/>
           </a:p>
@@ -10805,7 +10567,7 @@
                 <a:ea typeface="Calibri" pitchFamily="34" charset="-122"/>
                 <a:cs typeface="Calibri" pitchFamily="34" charset="-120"/>
               </a:rPr>
-              <a:t>Solo quien pasa esta llamada avanza a la visita presencial del edificio.</a:t>
+              <a:t>La dirección exacta y las cifras completas no se entregan en esta etapa — eso lo gestionan directamente los propietarios.</a:t>
             </a:r>
             <a:endParaRPr lang="en-US" sz="1350" dirty="0"/>
           </a:p>
@@ -10915,7 +10677,7 @@
                 <a:ea typeface="Calibri" pitchFamily="34" charset="-122"/>
                 <a:cs typeface="Calibri" pitchFamily="34" charset="-120"/>
               </a:rPr>
-              <a:t>ETAPA 04</a:t>
+              <a:t>ETAPA 03</a:t>
             </a:r>
             <a:endParaRPr lang="en-US" sz="1300" dirty="0"/>
           </a:p>
@@ -10930,23 +10692,23 @@
         <p:spPr>
           <a:xfrm>
             <a:off x="640080" y="777240"/>
-            <a:ext cx="7315200" cy="731520"/>
-          </a:xfrm>
-          <a:prstGeom prst="rect">
-            <a:avLst/>
-          </a:prstGeom>
-          <a:noFill/>
-          <a:ln/>
-        </p:spPr>
-        <p:txBody>
-          <a:bodyPr wrap="square" lIns="0" tIns="0" rIns="0" bIns="0" rtlCol="0" anchor="ctr"/>
-          <a:lstStyle/>
-          <a:p>
-            <a:pPr indent="0" marL="0">
-              <a:buNone/>
-            </a:pPr>
-            <a:r>
-              <a:rPr lang="en-US" sz="3200" b="1" dirty="0">
+            <a:ext cx="8229600" cy="731520"/>
+          </a:xfrm>
+          <a:prstGeom prst="rect">
+            <a:avLst/>
+          </a:prstGeom>
+          <a:noFill/>
+          <a:ln/>
+        </p:spPr>
+        <p:txBody>
+          <a:bodyPr wrap="square" lIns="0" tIns="0" rIns="0" bIns="0" rtlCol="0" anchor="ctr"/>
+          <a:lstStyle/>
+          <a:p>
+            <a:pPr indent="0" marL="0">
+              <a:buNone/>
+            </a:pPr>
+            <a:r>
+              <a:rPr lang="en-US" sz="3000" b="1" dirty="0">
                 <a:solidFill>
                   <a:srgbClr val="1C1F26"/>
                 </a:solidFill>
@@ -10954,9 +10716,9 @@
                 <a:ea typeface="Cambria" pitchFamily="34" charset="-122"/>
                 <a:cs typeface="Cambria" pitchFamily="34" charset="-120"/>
               </a:rPr>
-              <a:t>Visita y negociación</a:t>
-            </a:r>
-            <a:endParaRPr lang="en-US" sz="3200" dirty="0"/>
+              <a:t>Entrega de interesados calificados</a:t>
+            </a:r>
+            <a:endParaRPr lang="en-US" sz="3000" dirty="0"/>
           </a:p>
         </p:txBody>
       </p:sp>
@@ -10993,7 +10755,7 @@
                 <a:ea typeface="Calibri" pitchFamily="34" charset="-122"/>
                 <a:cs typeface="Calibri" pitchFamily="34" charset="-120"/>
               </a:rPr>
-              <a:t>Objetivo: convertir el interés calificado en una negociación de cierre.</a:t>
+              <a:t>Objetivo: traspasar a los propietarios contactos reales, listos para que ellos avancen.</a:t>
             </a:r>
             <a:endParaRPr lang="en-US" sz="1500" dirty="0"/>
           </a:p>
@@ -11021,7 +10783,7 @@
       </p:sp>
       <p:pic>
         <p:nvPicPr>
-          <p:cNvPr id="6" name="Image 0" descr="/tmp/hosty56_build/icons/handshake_gold.png">    </p:cNvPr>
+          <p:cNvPr id="6" name="Image 0" descr="/tmp/hosty56_build/icons/arrowRight_gold.png">    </p:cNvPr>
           <p:cNvPicPr>
             <a:picLocks noChangeAspect="1"/>
           </p:cNvPicPr>
@@ -11065,7 +10827,7 @@
       </p:sp>
       <p:pic>
         <p:nvPicPr>
-          <p:cNvPr id="8" name="Image 1" descr="/tmp/hosty56_build/icons/building_charcoal.png">    </p:cNvPr>
+          <p:cNvPr id="8" name="Image 1" descr="/tmp/hosty56_build/icons/checkCircle_charcoal.png">    </p:cNvPr>
           <p:cNvPicPr>
             <a:picLocks noChangeAspect="1"/>
           </p:cNvPicPr>
@@ -11120,7 +10882,7 @@
                 <a:ea typeface="Calibri" pitchFamily="34" charset="-122"/>
                 <a:cs typeface="Calibri" pitchFamily="34" charset="-120"/>
               </a:rPr>
-              <a:t>Visita presencial</a:t>
+              <a:t>Reporte de contacto</a:t>
             </a:r>
             <a:endParaRPr lang="en-US" sz="1600" dirty="0"/>
           </a:p>
@@ -11159,7 +10921,7 @@
                 <a:ea typeface="Calibri" pitchFamily="34" charset="-122"/>
                 <a:cs typeface="Calibri" pitchFamily="34" charset="-120"/>
               </a:rPr>
-              <a:t>Solo compradores que pasaron la llamada de interés conocen Hosty56 en persona.</a:t>
+              <a:t>Nombre, datos de contacto, respuestas del formulario y nivel de interés observado.</a:t>
             </a:r>
             <a:endParaRPr lang="en-US" sz="1350" dirty="0"/>
           </a:p>
@@ -11187,7 +10949,7 @@
       </p:sp>
       <p:pic>
         <p:nvPicPr>
-          <p:cNvPr id="12" name="Image 2" descr="/tmp/hosty56_build/icons/gavel_charcoal.png">    </p:cNvPr>
+          <p:cNvPr id="12" name="Image 2" descr="/tmp/hosty56_build/icons/handshake_charcoal.png">    </p:cNvPr>
           <p:cNvPicPr>
             <a:picLocks noChangeAspect="1"/>
           </p:cNvPicPr>
@@ -11242,7 +11004,7 @@
                 <a:ea typeface="Calibri" pitchFamily="34" charset="-122"/>
                 <a:cs typeface="Calibri" pitchFamily="34" charset="-120"/>
               </a:rPr>
-              <a:t>Negociación directa</a:t>
+              <a:t>Traspaso directo</a:t>
             </a:r>
             <a:endParaRPr lang="en-US" sz="1600" dirty="0"/>
           </a:p>
@@ -11281,7 +11043,7 @@
                 <a:ea typeface="Calibri" pitchFamily="34" charset="-122"/>
                 <a:cs typeface="Calibri" pitchFamily="34" charset="-120"/>
               </a:rPr>
-              <a:t>Se involucra a los propietarios y sus abogados para estructurar la oferta.</a:t>
+              <a:t>Los propietarios continúan con el NDA, el dossier, la llamada de verificación y la visita, por su cuenta.</a:t>
             </a:r>
             <a:endParaRPr lang="en-US" sz="1350" dirty="0"/>
           </a:p>
@@ -11364,7 +11126,7 @@
                 <a:ea typeface="Calibri" pitchFamily="34" charset="-122"/>
                 <a:cs typeface="Calibri" pitchFamily="34" charset="-120"/>
               </a:rPr>
-              <a:t>Cierre</a:t>
+              <a:t>Fin de mi alcance</a:t>
             </a:r>
             <a:endParaRPr lang="en-US" sz="1600" dirty="0"/>
           </a:p>
@@ -11403,7 +11165,7 @@
                 <a:ea typeface="Calibri" pitchFamily="34" charset="-122"/>
                 <a:cs typeface="Calibri" pitchFamily="34" charset="-120"/>
               </a:rPr>
-              <a:t>El objetivo final: un único comprador, en sociedad o directamente, adquiere el edificio completo.</a:t>
+              <a:t>Mi responsabilidad es la generación y calificación digital; el proceso de cierre lo gestionan ustedes.</a:t>
             </a:r>
             <a:endParaRPr lang="en-US" sz="1350" dirty="0"/>
           </a:p>

</xml_diff>